<commit_message>
PE comparison on real committed-capital returns (~8.6%, Phalippou) not headline IRR: add reconciliation-bridge slide; cite Meyer/Hayley/Buchner
</commit_message>
<xml_diff>
--- a/Athanase_vs_Private_Equity.pptx
+++ b/Athanase_vs_Private_Equity.pptx
@@ -6,6 +6,7 @@
   </p:sldMasterIdLst>
   <p:sldIdLst>
     <p:sldId id="256" r:id="rId7"/>
+    <p:sldId id="257" r:id="rId8"/>
   </p:sldIdLst>
   <p:sldSz cx="9753600" cy="7315200" type="screen4x3"/>
   <p:notesSz cx="6858000" cy="9144000"/>
@@ -3277,7 +3278,7 @@
                 </a:solidFill>
                 <a:latin typeface="Times New Roman"/>
               </a:rPr>
-              <a:t>Switching a private-equity sleeve into Athanase</a:t>
+              <a:t>Private equity’s headline return is not what you earn</a:t>
             </a:r>
           </a:p>
         </p:txBody>
@@ -3319,7 +3320,797 @@
                 </a:solidFill>
                 <a:latin typeface="Arial"/>
               </a:rPr>
-              <a:t>Same operational value creation — at a higher return, with liquidity, lower fees and daily transparency the private-equity wrapper gives up.</a:t>
+              <a:t>Headline IRR is struck on drawn capital only. Measured on the capital you commit — the honest basis — the return is far lower.</a:t>
+            </a:r>
+          </a:p>
+        </p:txBody>
+      </p:sp>
+      <p:pic>
+        <p:nvPicPr>
+          <p:cNvPr id="8" name="Picture 7" descr="pe_bridge.png"/>
+          <p:cNvPicPr>
+            <a:picLocks noChangeAspect="1"/>
+          </p:cNvPicPr>
+          <p:nvPr/>
+        </p:nvPicPr>
+        <p:blipFill>
+          <a:blip r:embed="rId3"/>
+          <a:stretch>
+            <a:fillRect/>
+          </a:stretch>
+        </p:blipFill>
+        <p:spPr>
+          <a:xfrm>
+            <a:off x="402346" y="2223819"/>
+            <a:ext cx="5850626" cy="2889576"/>
+          </a:xfrm>
+          <a:prstGeom prst="rect">
+            <a:avLst/>
+          </a:prstGeom>
+        </p:spPr>
+      </p:pic>
+      <p:sp>
+        <p:nvSpPr>
+          <p:cNvPr id="9" name="Rectangle 8"/>
+          <p:cNvSpPr/>
+          <p:nvPr/>
+        </p:nvSpPr>
+        <p:spPr>
+          <a:xfrm>
+            <a:off x="6547266" y="2262835"/>
+            <a:ext cx="2779845" cy="1170432"/>
+          </a:xfrm>
+          <a:prstGeom prst="rect">
+            <a:avLst/>
+          </a:prstGeom>
+          <a:solidFill>
+            <a:srgbClr val="F6F7F9"/>
+          </a:solidFill>
+          <a:ln>
+            <a:noFill/>
+          </a:ln>
+          <a:effectLst/>
+        </p:spPr>
+        <p:style>
+          <a:lnRef idx="1">
+            <a:schemeClr val="accent1"/>
+          </a:lnRef>
+          <a:fillRef idx="3">
+            <a:schemeClr val="accent1"/>
+          </a:fillRef>
+          <a:effectRef idx="2">
+            <a:schemeClr val="accent1"/>
+          </a:effectRef>
+          <a:fontRef idx="minor">
+            <a:schemeClr val="lt1"/>
+          </a:fontRef>
+        </p:style>
+        <p:txBody>
+          <a:bodyPr rtlCol="0" anchor="ctr"/>
+          <a:lstStyle/>
+          <a:p>
+            <a:pPr algn="ctr"/>
+          </a:p>
+        </p:txBody>
+      </p:sp>
+      <p:sp>
+        <p:nvSpPr>
+          <p:cNvPr id="10" name="TextBox 9"/>
+          <p:cNvSpPr txBox="1"/>
+          <p:nvPr/>
+        </p:nvSpPr>
+        <p:spPr>
+          <a:xfrm>
+            <a:off x="6693574" y="2379878"/>
+            <a:ext cx="2487230" cy="243840"/>
+          </a:xfrm>
+          <a:prstGeom prst="rect">
+            <a:avLst/>
+          </a:prstGeom>
+          <a:noFill/>
+        </p:spPr>
+        <p:txBody>
+          <a:bodyPr wrap="square" anchor="t" lIns="0" rIns="0" tIns="0" bIns="0">
+            <a:spAutoFit/>
+          </a:bodyPr>
+          <a:lstStyle/>
+          <a:p>
+            <a:pPr algn="l">
+              <a:lnSpc>
+                <a:spcPct val="110000"/>
+              </a:lnSpc>
+              <a:spcAft>
+                <a:spcPts val="0"/>
+              </a:spcAft>
+            </a:pPr>
+            <a:r>
+              <a:rPr sz="840" b="1" i="0">
+                <a:solidFill>
+                  <a:srgbClr val="314359"/>
+                </a:solidFill>
+                <a:latin typeface="Arial"/>
+              </a:rPr>
+              <a:t>THE REINVESTMENT TRICK</a:t>
+            </a:r>
+          </a:p>
+        </p:txBody>
+      </p:sp>
+      <p:sp>
+        <p:nvSpPr>
+          <p:cNvPr id="11" name="TextBox 10"/>
+          <p:cNvSpPr txBox="1"/>
+          <p:nvPr/>
+        </p:nvSpPr>
+        <p:spPr>
+          <a:xfrm>
+            <a:off x="6693574" y="2652979"/>
+            <a:ext cx="2487230" cy="731520"/>
+          </a:xfrm>
+          <a:prstGeom prst="rect">
+            <a:avLst/>
+          </a:prstGeom>
+          <a:noFill/>
+        </p:spPr>
+        <p:txBody>
+          <a:bodyPr wrap="square" anchor="t" lIns="0" rIns="0" tIns="0" bIns="0">
+            <a:spAutoFit/>
+          </a:bodyPr>
+          <a:lstStyle/>
+          <a:p>
+            <a:pPr algn="l">
+              <a:lnSpc>
+                <a:spcPct val="114000"/>
+              </a:lnSpc>
+              <a:spcAft>
+                <a:spcPts val="0"/>
+              </a:spcAft>
+            </a:pPr>
+            <a:r>
+              <a:rPr sz="880" b="0" i="0">
+                <a:solidFill>
+                  <a:srgbClr val="0E1620"/>
+                </a:solidFill>
+                <a:latin typeface="Arial"/>
+              </a:rPr>
+              <a:t>IRR assumes uncalled cash earns the IRR — inflating the figure by ~3 pts.</a:t>
+            </a:r>
+          </a:p>
+        </p:txBody>
+      </p:sp>
+      <p:sp>
+        <p:nvSpPr>
+          <p:cNvPr id="12" name="Rectangle 11"/>
+          <p:cNvSpPr/>
+          <p:nvPr/>
+        </p:nvSpPr>
+        <p:spPr>
+          <a:xfrm>
+            <a:off x="6547266" y="3589324"/>
+            <a:ext cx="2779845" cy="1170432"/>
+          </a:xfrm>
+          <a:prstGeom prst="rect">
+            <a:avLst/>
+          </a:prstGeom>
+          <a:solidFill>
+            <a:srgbClr val="F6F7F9"/>
+          </a:solidFill>
+          <a:ln>
+            <a:noFill/>
+          </a:ln>
+          <a:effectLst/>
+        </p:spPr>
+        <p:style>
+          <a:lnRef idx="1">
+            <a:schemeClr val="accent1"/>
+          </a:lnRef>
+          <a:fillRef idx="3">
+            <a:schemeClr val="accent1"/>
+          </a:fillRef>
+          <a:effectRef idx="2">
+            <a:schemeClr val="accent1"/>
+          </a:effectRef>
+          <a:fontRef idx="minor">
+            <a:schemeClr val="lt1"/>
+          </a:fontRef>
+        </p:style>
+        <p:txBody>
+          <a:bodyPr rtlCol="0" anchor="ctr"/>
+          <a:lstStyle/>
+          <a:p>
+            <a:pPr algn="ctr"/>
+          </a:p>
+        </p:txBody>
+      </p:sp>
+      <p:sp>
+        <p:nvSpPr>
+          <p:cNvPr id="13" name="TextBox 12"/>
+          <p:cNvSpPr txBox="1"/>
+          <p:nvPr/>
+        </p:nvSpPr>
+        <p:spPr>
+          <a:xfrm>
+            <a:off x="6693574" y="3706368"/>
+            <a:ext cx="2487230" cy="243840"/>
+          </a:xfrm>
+          <a:prstGeom prst="rect">
+            <a:avLst/>
+          </a:prstGeom>
+          <a:noFill/>
+        </p:spPr>
+        <p:txBody>
+          <a:bodyPr wrap="square" anchor="t" lIns="0" rIns="0" tIns="0" bIns="0">
+            <a:spAutoFit/>
+          </a:bodyPr>
+          <a:lstStyle/>
+          <a:p>
+            <a:pPr algn="l">
+              <a:lnSpc>
+                <a:spcPct val="110000"/>
+              </a:lnSpc>
+              <a:spcAft>
+                <a:spcPts val="0"/>
+              </a:spcAft>
+            </a:pPr>
+            <a:r>
+              <a:rPr sz="840" b="1" i="0">
+                <a:solidFill>
+                  <a:srgbClr val="314359"/>
+                </a:solidFill>
+                <a:latin typeface="Arial"/>
+              </a:rPr>
+              <a:t>THE COMMITTED-CAPITAL DRAG</a:t>
+            </a:r>
+          </a:p>
+        </p:txBody>
+      </p:sp>
+      <p:sp>
+        <p:nvSpPr>
+          <p:cNvPr id="14" name="TextBox 13"/>
+          <p:cNvSpPr txBox="1"/>
+          <p:nvPr/>
+        </p:nvSpPr>
+        <p:spPr>
+          <a:xfrm>
+            <a:off x="6693574" y="3979468"/>
+            <a:ext cx="2487230" cy="731520"/>
+          </a:xfrm>
+          <a:prstGeom prst="rect">
+            <a:avLst/>
+          </a:prstGeom>
+          <a:noFill/>
+        </p:spPr>
+        <p:txBody>
+          <a:bodyPr wrap="square" anchor="t" lIns="0" rIns="0" tIns="0" bIns="0">
+            <a:spAutoFit/>
+          </a:bodyPr>
+          <a:lstStyle/>
+          <a:p>
+            <a:pPr algn="l">
+              <a:lnSpc>
+                <a:spcPct val="114000"/>
+              </a:lnSpc>
+              <a:spcAft>
+                <a:spcPts val="0"/>
+              </a:spcAft>
+            </a:pPr>
+            <a:r>
+              <a:rPr sz="880" b="0" i="0">
+                <a:solidFill>
+                  <a:srgbClr val="0E1620"/>
+                </a:solidFill>
+                <a:latin typeface="Arial"/>
+              </a:rPr>
+              <a:t>You commit 100 but ~half sits in cash earning little, while paying fees — overstating returns by up to ~50%.</a:t>
+            </a:r>
+          </a:p>
+        </p:txBody>
+      </p:sp>
+      <p:sp>
+        <p:nvSpPr>
+          <p:cNvPr id="15" name="Rectangle 14"/>
+          <p:cNvSpPr/>
+          <p:nvPr/>
+        </p:nvSpPr>
+        <p:spPr>
+          <a:xfrm>
+            <a:off x="6547266" y="4915814"/>
+            <a:ext cx="2779845" cy="1170432"/>
+          </a:xfrm>
+          <a:prstGeom prst="rect">
+            <a:avLst/>
+          </a:prstGeom>
+          <a:solidFill>
+            <a:srgbClr val="F6F7F9"/>
+          </a:solidFill>
+          <a:ln>
+            <a:noFill/>
+          </a:ln>
+          <a:effectLst/>
+        </p:spPr>
+        <p:style>
+          <a:lnRef idx="1">
+            <a:schemeClr val="accent1"/>
+          </a:lnRef>
+          <a:fillRef idx="3">
+            <a:schemeClr val="accent1"/>
+          </a:fillRef>
+          <a:effectRef idx="2">
+            <a:schemeClr val="accent1"/>
+          </a:effectRef>
+          <a:fontRef idx="minor">
+            <a:schemeClr val="lt1"/>
+          </a:fontRef>
+        </p:style>
+        <p:txBody>
+          <a:bodyPr rtlCol="0" anchor="ctr"/>
+          <a:lstStyle/>
+          <a:p>
+            <a:pPr algn="ctr"/>
+          </a:p>
+        </p:txBody>
+      </p:sp>
+      <p:sp>
+        <p:nvSpPr>
+          <p:cNvPr id="16" name="TextBox 15"/>
+          <p:cNvSpPr txBox="1"/>
+          <p:nvPr/>
+        </p:nvSpPr>
+        <p:spPr>
+          <a:xfrm>
+            <a:off x="6693574" y="5032857"/>
+            <a:ext cx="2487230" cy="243840"/>
+          </a:xfrm>
+          <a:prstGeom prst="rect">
+            <a:avLst/>
+          </a:prstGeom>
+          <a:noFill/>
+        </p:spPr>
+        <p:txBody>
+          <a:bodyPr wrap="square" anchor="t" lIns="0" rIns="0" tIns="0" bIns="0">
+            <a:spAutoFit/>
+          </a:bodyPr>
+          <a:lstStyle/>
+          <a:p>
+            <a:pPr algn="l">
+              <a:lnSpc>
+                <a:spcPct val="110000"/>
+              </a:lnSpc>
+              <a:spcAft>
+                <a:spcPts val="0"/>
+              </a:spcAft>
+            </a:pPr>
+            <a:r>
+              <a:rPr sz="840" b="1" i="0">
+                <a:solidFill>
+                  <a:srgbClr val="314359"/>
+                </a:solidFill>
+                <a:latin typeface="Arial"/>
+              </a:rPr>
+              <a:t>THE LIKE-FOR-LIKE TRUTH</a:t>
+            </a:r>
+          </a:p>
+        </p:txBody>
+      </p:sp>
+      <p:sp>
+        <p:nvSpPr>
+          <p:cNvPr id="17" name="TextBox 16"/>
+          <p:cNvSpPr txBox="1"/>
+          <p:nvPr/>
+        </p:nvSpPr>
+        <p:spPr>
+          <a:xfrm>
+            <a:off x="6693574" y="5305958"/>
+            <a:ext cx="2487230" cy="731520"/>
+          </a:xfrm>
+          <a:prstGeom prst="rect">
+            <a:avLst/>
+          </a:prstGeom>
+          <a:noFill/>
+        </p:spPr>
+        <p:txBody>
+          <a:bodyPr wrap="square" anchor="t" lIns="0" rIns="0" tIns="0" bIns="0">
+            <a:spAutoFit/>
+          </a:bodyPr>
+          <a:lstStyle/>
+          <a:p>
+            <a:pPr algn="l">
+              <a:lnSpc>
+                <a:spcPct val="114000"/>
+              </a:lnSpc>
+              <a:spcAft>
+                <a:spcPts val="0"/>
+              </a:spcAft>
+            </a:pPr>
+            <a:r>
+              <a:rPr sz="880" b="0" i="0">
+                <a:solidFill>
+                  <a:srgbClr val="0E1620"/>
+                </a:solidFill>
+                <a:latin typeface="Arial"/>
+              </a:rPr>
+              <a:t>On a public-market-equivalent basis, 2006–18 PE returned ~8.6% — about the same as the S&amp;P 500, after $400bn+ in fees.</a:t>
+            </a:r>
+          </a:p>
+        </p:txBody>
+      </p:sp>
+      <p:sp>
+        <p:nvSpPr>
+          <p:cNvPr id="18" name="Rectangle 17"/>
+          <p:cNvSpPr/>
+          <p:nvPr/>
+        </p:nvSpPr>
+        <p:spPr>
+          <a:xfrm>
+            <a:off x="438922" y="6456883"/>
+            <a:ext cx="8873559" cy="448665"/>
+          </a:xfrm>
+          <a:prstGeom prst="rect">
+            <a:avLst/>
+          </a:prstGeom>
+          <a:solidFill>
+            <a:srgbClr val="152130"/>
+          </a:solidFill>
+          <a:ln>
+            <a:noFill/>
+          </a:ln>
+          <a:effectLst/>
+        </p:spPr>
+        <p:style>
+          <a:lnRef idx="1">
+            <a:schemeClr val="accent1"/>
+          </a:lnRef>
+          <a:fillRef idx="3">
+            <a:schemeClr val="accent1"/>
+          </a:fillRef>
+          <a:effectRef idx="2">
+            <a:schemeClr val="accent1"/>
+          </a:effectRef>
+          <a:fontRef idx="minor">
+            <a:schemeClr val="lt1"/>
+          </a:fontRef>
+        </p:style>
+        <p:txBody>
+          <a:bodyPr rtlCol="0" anchor="ctr"/>
+          <a:lstStyle/>
+          <a:p>
+            <a:pPr algn="ctr"/>
+          </a:p>
+        </p:txBody>
+      </p:sp>
+      <p:sp>
+        <p:nvSpPr>
+          <p:cNvPr id="19" name="TextBox 18"/>
+          <p:cNvSpPr txBox="1"/>
+          <p:nvPr/>
+        </p:nvSpPr>
+        <p:spPr>
+          <a:xfrm>
+            <a:off x="570599" y="6456883"/>
+            <a:ext cx="8632151" cy="448665"/>
+          </a:xfrm>
+          <a:prstGeom prst="rect">
+            <a:avLst/>
+          </a:prstGeom>
+          <a:noFill/>
+        </p:spPr>
+        <p:txBody>
+          <a:bodyPr wrap="square" anchor="ctr" lIns="0" rIns="0" tIns="0" bIns="0">
+            <a:spAutoFit/>
+          </a:bodyPr>
+          <a:lstStyle/>
+          <a:p>
+            <a:pPr algn="l">
+              <a:lnSpc>
+                <a:spcPct val="110000"/>
+              </a:lnSpc>
+              <a:spcAft>
+                <a:spcPts val="0"/>
+              </a:spcAft>
+            </a:pPr>
+            <a:r>
+              <a:rPr sz="960" b="0" i="1">
+                <a:solidFill>
+                  <a:srgbClr val="FFFFFF"/>
+                </a:solidFill>
+                <a:latin typeface="Arial"/>
+              </a:rPr>
+              <a:t>Athanase’s 16% is already a committed-capital return — fully invested from day one. Compared like-for-like, it is roughly double real PE.</a:t>
+            </a:r>
+          </a:p>
+        </p:txBody>
+      </p:sp>
+      <p:sp>
+        <p:nvSpPr>
+          <p:cNvPr id="20" name="TextBox 19"/>
+          <p:cNvSpPr txBox="1"/>
+          <p:nvPr/>
+        </p:nvSpPr>
+        <p:spPr>
+          <a:xfrm>
+            <a:off x="438922" y="6925056"/>
+            <a:ext cx="9217382" cy="487680"/>
+          </a:xfrm>
+          <a:prstGeom prst="rect">
+            <a:avLst/>
+          </a:prstGeom>
+          <a:noFill/>
+        </p:spPr>
+        <p:txBody>
+          <a:bodyPr wrap="square" anchor="t" lIns="0" rIns="0" tIns="0" bIns="0">
+            <a:spAutoFit/>
+          </a:bodyPr>
+          <a:lstStyle/>
+          <a:p>
+            <a:pPr algn="l">
+              <a:lnSpc>
+                <a:spcPct val="110000"/>
+              </a:lnSpc>
+              <a:spcAft>
+                <a:spcPts val="0"/>
+              </a:spcAft>
+            </a:pPr>
+            <a:r>
+              <a:rPr sz="600" b="0" i="0">
+                <a:solidFill>
+                  <a:srgbClr val="556A83"/>
+                </a:solidFill>
+                <a:latin typeface="Arial"/>
+              </a:rPr>
+              <a:t>Sources: top-quartile headline IRR ~18–22% (Cambridge Associates US PE benchmark, 2024); real ~8.6% public-market-equivalent return, 2006–18 (Phalippou, 2020); committed-capital / undrawn-commitment drag (Meyer, 2020, J. Alternative Investments; Hayley &amp; Sefiloglu, 2022; Buchner, Kaserer &amp; Wagner, 2010). Bridge magnitudes illustrative, reconciling cited endpoints. Athanase real, net, 2006–2025.</a:t>
+            </a:r>
+          </a:p>
+        </p:txBody>
+      </p:sp>
+    </p:spTree>
+  </p:cSld>
+  <p:clrMapOvr>
+    <a:masterClrMapping/>
+  </p:clrMapOvr>
+</p:sld>
+</file>
+
+<file path=ppt/slides/slide2.xml><?xml version="1.0" encoding="utf-8"?>
+<p:sld xmlns:a="http://schemas.openxmlformats.org/drawingml/2006/main" xmlns:p="http://schemas.openxmlformats.org/presentationml/2006/main" xmlns:r="http://schemas.openxmlformats.org/officeDocument/2006/relationships">
+  <p:cSld>
+    <p:spTree>
+      <p:nvGrpSpPr>
+        <p:cNvPr id="1" name=""/>
+        <p:cNvGrpSpPr/>
+        <p:nvPr/>
+      </p:nvGrpSpPr>
+      <p:grpSpPr/>
+      <p:pic>
+        <p:nvPicPr>
+          <p:cNvPr id="2" name="Picture 1" descr="mark_dark.png"/>
+          <p:cNvPicPr>
+            <a:picLocks noChangeAspect="1"/>
+          </p:cNvPicPr>
+          <p:nvPr/>
+        </p:nvPicPr>
+        <p:blipFill>
+          <a:blip r:embed="rId2"/>
+          <a:stretch>
+            <a:fillRect/>
+          </a:stretch>
+        </p:blipFill>
+        <p:spPr>
+          <a:xfrm>
+            <a:off x="402346" y="234086"/>
+            <a:ext cx="224012" cy="190199"/>
+          </a:xfrm>
+          <a:prstGeom prst="rect">
+            <a:avLst/>
+          </a:prstGeom>
+        </p:spPr>
+      </p:pic>
+      <p:sp>
+        <p:nvSpPr>
+          <p:cNvPr id="3" name="TextBox 2"/>
+          <p:cNvSpPr txBox="1"/>
+          <p:nvPr/>
+        </p:nvSpPr>
+        <p:spPr>
+          <a:xfrm>
+            <a:off x="716907" y="263347"/>
+            <a:ext cx="5120768" cy="292608"/>
+          </a:xfrm>
+          <a:prstGeom prst="rect">
+            <a:avLst/>
+          </a:prstGeom>
+          <a:noFill/>
+        </p:spPr>
+        <p:txBody>
+          <a:bodyPr wrap="square" anchor="t" lIns="0" rIns="0" tIns="0" bIns="0">
+            <a:spAutoFit/>
+          </a:bodyPr>
+          <a:lstStyle/>
+          <a:p>
+            <a:pPr algn="l">
+              <a:lnSpc>
+                <a:spcPct val="110000"/>
+              </a:lnSpc>
+              <a:spcAft>
+                <a:spcPts val="0"/>
+              </a:spcAft>
+            </a:pPr>
+            <a:r>
+              <a:rPr sz="880" b="0" i="0">
+                <a:solidFill>
+                  <a:srgbClr val="556A83"/>
+                </a:solidFill>
+                <a:latin typeface="Arial"/>
+              </a:rPr>
+              <a:t>Risk-Adjusted Outcomes</a:t>
+            </a:r>
+          </a:p>
+        </p:txBody>
+      </p:sp>
+      <p:sp>
+        <p:nvSpPr>
+          <p:cNvPr id="4" name="TextBox 3"/>
+          <p:cNvSpPr txBox="1"/>
+          <p:nvPr/>
+        </p:nvSpPr>
+        <p:spPr>
+          <a:xfrm>
+            <a:off x="7242229" y="263347"/>
+            <a:ext cx="2084884" cy="292608"/>
+          </a:xfrm>
+          <a:prstGeom prst="rect">
+            <a:avLst/>
+          </a:prstGeom>
+          <a:noFill/>
+        </p:spPr>
+        <p:txBody>
+          <a:bodyPr wrap="square" anchor="t" lIns="0" rIns="0" tIns="0" bIns="0">
+            <a:spAutoFit/>
+          </a:bodyPr>
+          <a:lstStyle/>
+          <a:p>
+            <a:pPr algn="r">
+              <a:lnSpc>
+                <a:spcPct val="110000"/>
+              </a:lnSpc>
+              <a:spcAft>
+                <a:spcPts val="0"/>
+              </a:spcAft>
+            </a:pPr>
+            <a:r>
+              <a:rPr sz="880" b="1" i="0">
+                <a:solidFill>
+                  <a:srgbClr val="556A83"/>
+                </a:solidFill>
+                <a:latin typeface="Arial"/>
+              </a:rPr>
+              <a:t>Figure 2</a:t>
+            </a:r>
+          </a:p>
+        </p:txBody>
+      </p:sp>
+      <p:sp>
+        <p:nvSpPr>
+          <p:cNvPr id="5" name="Rectangle 4"/>
+          <p:cNvSpPr/>
+          <p:nvPr/>
+        </p:nvSpPr>
+        <p:spPr>
+          <a:xfrm>
+            <a:off x="0" y="604723"/>
+            <a:ext cx="9753600" cy="1414272"/>
+          </a:xfrm>
+          <a:prstGeom prst="rect">
+            <a:avLst/>
+          </a:prstGeom>
+          <a:solidFill>
+            <a:srgbClr val="F6F7F9"/>
+          </a:solidFill>
+          <a:ln>
+            <a:noFill/>
+          </a:ln>
+          <a:effectLst/>
+        </p:spPr>
+        <p:style>
+          <a:lnRef idx="1">
+            <a:schemeClr val="accent1"/>
+          </a:lnRef>
+          <a:fillRef idx="3">
+            <a:schemeClr val="accent1"/>
+          </a:fillRef>
+          <a:effectRef idx="2">
+            <a:schemeClr val="accent1"/>
+          </a:effectRef>
+          <a:fontRef idx="minor">
+            <a:schemeClr val="lt1"/>
+          </a:fontRef>
+        </p:style>
+        <p:txBody>
+          <a:bodyPr rtlCol="0" anchor="ctr"/>
+          <a:lstStyle/>
+          <a:p>
+            <a:pPr algn="ctr"/>
+          </a:p>
+        </p:txBody>
+      </p:sp>
+      <p:sp>
+        <p:nvSpPr>
+          <p:cNvPr id="6" name="TextBox 5"/>
+          <p:cNvSpPr txBox="1"/>
+          <p:nvPr/>
+        </p:nvSpPr>
+        <p:spPr>
+          <a:xfrm>
+            <a:off x="438922" y="721766"/>
+            <a:ext cx="8851613" cy="829056"/>
+          </a:xfrm>
+          <a:prstGeom prst="rect">
+            <a:avLst/>
+          </a:prstGeom>
+          <a:noFill/>
+        </p:spPr>
+        <p:txBody>
+          <a:bodyPr wrap="square" anchor="t" lIns="0" rIns="0" tIns="0" bIns="0">
+            <a:spAutoFit/>
+          </a:bodyPr>
+          <a:lstStyle/>
+          <a:p>
+            <a:pPr algn="l">
+              <a:lnSpc>
+                <a:spcPct val="110000"/>
+              </a:lnSpc>
+              <a:spcAft>
+                <a:spcPts val="200"/>
+              </a:spcAft>
+            </a:pPr>
+            <a:r>
+              <a:rPr sz="2400" b="0" i="0">
+                <a:solidFill>
+                  <a:srgbClr val="314359"/>
+                </a:solidFill>
+                <a:latin typeface="Times New Roman"/>
+              </a:rPr>
+              <a:t>Switching a private-equity sleeve into Athanase</a:t>
+            </a:r>
+          </a:p>
+        </p:txBody>
+      </p:sp>
+      <p:sp>
+        <p:nvSpPr>
+          <p:cNvPr id="7" name="TextBox 6"/>
+          <p:cNvSpPr txBox="1"/>
+          <p:nvPr/>
+        </p:nvSpPr>
+        <p:spPr>
+          <a:xfrm>
+            <a:off x="453553" y="1511808"/>
+            <a:ext cx="8705305" cy="487680"/>
+          </a:xfrm>
+          <a:prstGeom prst="rect">
+            <a:avLst/>
+          </a:prstGeom>
+          <a:noFill/>
+        </p:spPr>
+        <p:txBody>
+          <a:bodyPr wrap="square" anchor="t" lIns="0" rIns="0" tIns="0" bIns="0">
+            <a:spAutoFit/>
+          </a:bodyPr>
+          <a:lstStyle/>
+          <a:p>
+            <a:pPr algn="l">
+              <a:lnSpc>
+                <a:spcPct val="110000"/>
+              </a:lnSpc>
+              <a:spcAft>
+                <a:spcPts val="0"/>
+              </a:spcAft>
+            </a:pPr>
+            <a:r>
+              <a:rPr sz="1040" b="0" i="1">
+                <a:solidFill>
+                  <a:srgbClr val="556A83"/>
+                </a:solidFill>
+                <a:latin typeface="Arial"/>
+              </a:rPr>
+              <a:t>On the honest numbers, Athanase out-returns real PE with more liquidity, lower fees and daily transparency.</a:t>
             </a:r>
           </a:p>
         </p:txBody>
@@ -3356,8 +4147,8 @@
         </p:nvSpPr>
         <p:spPr>
           <a:xfrm>
-            <a:off x="512076" y="6096000"/>
-            <a:ext cx="4535537" cy="487680"/>
+            <a:off x="512076" y="6125260"/>
+            <a:ext cx="4535537" cy="390144"/>
           </a:xfrm>
           <a:prstGeom prst="rect">
             <a:avLst/>
@@ -3385,7 +4176,7 @@
                 </a:solidFill>
                 <a:latin typeface="Arial"/>
               </a:rPr>
-              <a:t>Marked daily like Athanase, PE’s appraisal-smoothed risk roughly doubles — its “low volatility” is largely an accounting artefact.</a:t>
+              <a:t>Measured honestly, PE moves down and to the right — lower return, higher true risk — while Athanase sits up and to the left.</a:t>
             </a:r>
           </a:p>
         </p:txBody>
@@ -3513,7 +4304,7 @@
                 </a:solidFill>
                 <a:latin typeface="Times New Roman"/>
               </a:rPr>
-              <a:t>+3 pts net</a:t>
+              <a:t>~16% vs ~9% real</a:t>
             </a:r>
           </a:p>
         </p:txBody>
@@ -3555,7 +4346,7 @@
                 </a:solidFill>
                 <a:latin typeface="Arial"/>
               </a:rPr>
-              <a:t>16% vs ~13% net IRR — more return, not less, for the switch.</a:t>
+              <a:t>Roughly double real PE on a committed-capital basis.</a:t>
             </a:r>
           </a:p>
         </p:txBody>
@@ -3895,7 +4686,7 @@
                 </a:solidFill>
                 <a:latin typeface="Arial"/>
               </a:rPr>
-              <a:t>No 2&amp;20 on undeployed dry powder waiting in a queue.</a:t>
+              <a:t>No fees on undeployed dry powder waiting in a queue.</a:t>
             </a:r>
           </a:p>
         </p:txBody>
@@ -4321,7 +5112,7 @@
                 </a:solidFill>
                 <a:latin typeface="Arial"/>
               </a:rPr>
-              <a:t>Switching a PE sleeve into Athanase keeps the operational upside but adds return, liquidity and transparency — and removes the smoothing that hides PE’s true risk.</a:t>
+              <a:t>Switching a PE sleeve into Athanase keeps the operational upside but adds return, liquidity and transparency — once PE is measured the way you actually experience it.</a:t>
             </a:r>
           </a:p>
         </p:txBody>
@@ -4363,7 +5154,7 @@
                 </a:solidFill>
                 <a:latin typeface="Arial"/>
               </a:rPr>
-              <a:t>Athanase: net monthly returns, 235 months (2006–2025), real. *Mid-market PE shown from assumptions (≈13% net IRR; reported downside ≈7%, de-smoothed ≈13% for appraisal autocorrelation), not a supplied return series. Illustrative; past performance is not indicative of future results.</a:t>
+              <a:t>Athanase: net monthly returns, 235 months (2006–2025), real. PE real return ~8.6% committed basis (Phalippou, 2020); downside vol reported ~7% de-smoothed to ~13% (MSCI; Morningstar). Illustrative; past performance is not indicative of future results.</a:t>
             </a:r>
           </a:p>
         </p:txBody>

</xml_diff>

<commit_message>
Use real allocator-realised PE returns (Cliffwater 11.4%, BVCA 14.1% vs PME) instead of Phalippou floor; rebuild slide 1 as realised-returns evidence chart
</commit_message>
<xml_diff>
--- a/Athanase_vs_Private_Equity.pptx
+++ b/Athanase_vs_Private_Equity.pptx
@@ -3278,7 +3278,7 @@
                 </a:solidFill>
                 <a:latin typeface="Times New Roman"/>
               </a:rPr>
-              <a:t>Private equity’s headline return is not what you earn</a:t>
+              <a:t>What allocators actually earn from private equity</a:t>
             </a:r>
           </a:p>
         </p:txBody>
@@ -3320,14 +3320,14 @@
                 </a:solidFill>
                 <a:latin typeface="Arial"/>
               </a:rPr>
-              <a:t>Headline IRR is struck on drawn capital only. Measured on the capital you commit — the honest basis — the return is far lower.</a:t>
+              <a:t>Stripping out headline-IRR marketing, cash-matched (PME) data shows PE earns a real ~3–6 pt premium over public markets — but lands below Athanase.</a:t>
             </a:r>
           </a:p>
         </p:txBody>
       </p:sp>
       <p:pic>
         <p:nvPicPr>
-          <p:cNvPr id="8" name="Picture 7" descr="pe_bridge.png"/>
+          <p:cNvPr id="8" name="Picture 7" descr="pe_realised.png"/>
           <p:cNvPicPr>
             <a:picLocks noChangeAspect="1"/>
           </p:cNvPicPr>
@@ -3342,7 +3342,7 @@
         <p:spPr>
           <a:xfrm>
             <a:off x="402346" y="2223819"/>
-            <a:ext cx="5850626" cy="2889576"/>
+            <a:ext cx="5941604" cy="2889576"/>
           </a:xfrm>
           <a:prstGeom prst="rect">
             <a:avLst/>
@@ -3401,7 +3401,7 @@
         </p:nvSpPr>
         <p:spPr>
           <a:xfrm>
-            <a:off x="6693574" y="2379878"/>
+            <a:off x="6693574" y="2360371"/>
             <a:ext cx="2487230" cy="243840"/>
           </a:xfrm>
           <a:prstGeom prst="rect">
@@ -3430,7 +3430,7 @@
                 </a:solidFill>
                 <a:latin typeface="Arial"/>
               </a:rPr>
-              <a:t>THE REINVESTMENT TRICK</a:t>
+              <a:t>HEADLINE ≠ REALISED</a:t>
             </a:r>
           </a:p>
         </p:txBody>
@@ -3443,8 +3443,8 @@
         </p:nvSpPr>
         <p:spPr>
           <a:xfrm>
-            <a:off x="6693574" y="2652979"/>
-            <a:ext cx="2487230" cy="731520"/>
+            <a:off x="6693574" y="2613964"/>
+            <a:ext cx="2487230" cy="780288"/>
           </a:xfrm>
           <a:prstGeom prst="rect">
             <a:avLst/>
@@ -3459,20 +3459,20 @@
           <a:p>
             <a:pPr algn="l">
               <a:lnSpc>
-                <a:spcPct val="114000"/>
+                <a:spcPct val="112000"/>
               </a:lnSpc>
               <a:spcAft>
                 <a:spcPts val="0"/>
               </a:spcAft>
             </a:pPr>
             <a:r>
-              <a:rPr sz="880" b="0" i="0">
+              <a:rPr sz="840" b="0" i="0">
                 <a:solidFill>
                   <a:srgbClr val="0E1620"/>
                 </a:solidFill>
                 <a:latin typeface="Arial"/>
               </a:rPr>
-              <a:t>IRR assumes uncalled cash earns the IRR — inflating the figure by ~3 pts.</a:t>
+              <a:t>Top-quartile IRR is shown as ~18–22%, struck on drawn capital. Cash-matched to public markets, the real figure is far lower.</a:t>
             </a:r>
           </a:p>
         </p:txBody>
@@ -3529,7 +3529,7 @@
         </p:nvSpPr>
         <p:spPr>
           <a:xfrm>
-            <a:off x="6693574" y="3706368"/>
+            <a:off x="6693574" y="3686860"/>
             <a:ext cx="2487230" cy="243840"/>
           </a:xfrm>
           <a:prstGeom prst="rect">
@@ -3558,7 +3558,7 @@
                 </a:solidFill>
                 <a:latin typeface="Arial"/>
               </a:rPr>
-              <a:t>THE COMMITTED-CAPITAL DRAG</a:t>
+              <a:t>THE REAL PREMIUM IS GENUINE</a:t>
             </a:r>
           </a:p>
         </p:txBody>
@@ -3571,8 +3571,8 @@
         </p:nvSpPr>
         <p:spPr>
           <a:xfrm>
-            <a:off x="6693574" y="3979468"/>
-            <a:ext cx="2487230" cy="731520"/>
+            <a:off x="6693574" y="3940454"/>
+            <a:ext cx="2487230" cy="780288"/>
           </a:xfrm>
           <a:prstGeom prst="rect">
             <a:avLst/>
@@ -3587,20 +3587,20 @@
           <a:p>
             <a:pPr algn="l">
               <a:lnSpc>
-                <a:spcPct val="114000"/>
+                <a:spcPct val="112000"/>
               </a:lnSpc>
               <a:spcAft>
                 <a:spcPts val="0"/>
               </a:spcAft>
             </a:pPr>
             <a:r>
-              <a:rPr sz="880" b="0" i="0">
+              <a:rPr sz="840" b="0" i="0">
                 <a:solidFill>
                   <a:srgbClr val="0E1620"/>
                 </a:solidFill>
                 <a:latin typeface="Arial"/>
               </a:rPr>
-              <a:t>You commit 100 but ~half sits in cash earning little, while paying fees — overstating returns by up to ~50%.</a:t>
+              <a:t>PME studies agree: ~1.2× wealth multiple, a real 3–5 pt premium over public equities (Cambridge; Kaplan-Schoar / Burgiss; Cliffwater; BVCA).</a:t>
             </a:r>
           </a:p>
         </p:txBody>
@@ -3657,7 +3657,7 @@
         </p:nvSpPr>
         <p:spPr>
           <a:xfrm>
-            <a:off x="6693574" y="5032857"/>
+            <a:off x="6693574" y="5013350"/>
             <a:ext cx="2487230" cy="243840"/>
           </a:xfrm>
           <a:prstGeom prst="rect">
@@ -3686,7 +3686,7 @@
                 </a:solidFill>
                 <a:latin typeface="Arial"/>
               </a:rPr>
-              <a:t>THE LIKE-FOR-LIKE TRUTH</a:t>
+              <a:t>BUT BELOW ATHANASE</a:t>
             </a:r>
           </a:p>
         </p:txBody>
@@ -3699,8 +3699,8 @@
         </p:nvSpPr>
         <p:spPr>
           <a:xfrm>
-            <a:off x="6693574" y="5305958"/>
-            <a:ext cx="2487230" cy="731520"/>
+            <a:off x="6693574" y="5266944"/>
+            <a:ext cx="2487230" cy="780288"/>
           </a:xfrm>
           <a:prstGeom prst="rect">
             <a:avLst/>
@@ -3715,20 +3715,20 @@
           <a:p>
             <a:pPr algn="l">
               <a:lnSpc>
-                <a:spcPct val="114000"/>
+                <a:spcPct val="112000"/>
               </a:lnSpc>
               <a:spcAft>
                 <a:spcPts val="0"/>
               </a:spcAft>
             </a:pPr>
             <a:r>
-              <a:rPr sz="880" b="0" i="0">
+              <a:rPr sz="840" b="0" i="0">
                 <a:solidFill>
                   <a:srgbClr val="0E1620"/>
                 </a:solidFill>
                 <a:latin typeface="Arial"/>
               </a:rPr>
-              <a:t>On a public-market-equivalent basis, 2006–18 PE returned ~8.6% — about the same as the S&amp;P 500, after $400bn+ in fees.</a:t>
+              <a:t>Allocators realise ~11–14% from PE. Athanase has delivered ~16% — net, real, and fully invested from day one.</a:t>
             </a:r>
           </a:p>
         </p:txBody>
@@ -3814,7 +3814,7 @@
                 </a:solidFill>
                 <a:latin typeface="Arial"/>
               </a:rPr>
-              <a:t>Athanase’s 16% is already a committed-capital return — fully invested from day one. Compared like-for-like, it is roughly double real PE.</a:t>
+              <a:t>PE’s premium over public markets is real — but Athanase’s ~16% sits above even what the best allocators realise, with daily liquidity.</a:t>
             </a:r>
           </a:p>
         </p:txBody>
@@ -3856,7 +3856,7 @@
                 </a:solidFill>
                 <a:latin typeface="Arial"/>
               </a:rPr>
-              <a:t>Sources: top-quartile headline IRR ~18–22% (Cambridge Associates US PE benchmark, 2024); real ~8.6% public-market-equivalent return, 2006–18 (Phalippou, 2020); committed-capital / undrawn-commitment drag (Meyer, 2020, J. Alternative Investments; Hayley &amp; Sefiloglu, 2022; Buchner, Kaserer &amp; Wagner, 2010). Bridge magnitudes illustrative, reconciling cited endpoints. Athanase real, net, 2006–2025.</a:t>
+              <a:t>Sources: Cliffwater (US state pensions, 2000–2022): PE 11.4% vs PME 5.8%. BVCA / Capital Dynamics (UK &amp; Europe, 2001–2023): 14.1% vs 7.7% (PME+). Corroborated by Cambridge Associates mPME (1.15–1.25×) and Kaplan-Harris-Jenkinson KS-PME on Burgiss (1.20–1.27×), ≈ +3 pts/yr. Athanase real, net, 2006–2025.</a:t>
             </a:r>
           </a:p>
         </p:txBody>
@@ -4304,7 +4304,7 @@
                 </a:solidFill>
                 <a:latin typeface="Times New Roman"/>
               </a:rPr>
-              <a:t>~16% vs ~9% real</a:t>
+              <a:t>~16% vs ~11–14% realised</a:t>
             </a:r>
           </a:p>
         </p:txBody>
@@ -4346,7 +4346,7 @@
                 </a:solidFill>
                 <a:latin typeface="Arial"/>
               </a:rPr>
-              <a:t>Roughly double real PE on a committed-capital basis.</a:t>
+              <a:t>Above what even the best allocators realise from PE (Cliffwater; BVCA).</a:t>
             </a:r>
           </a:p>
         </p:txBody>
@@ -5154,7 +5154,7 @@
                 </a:solidFill>
                 <a:latin typeface="Arial"/>
               </a:rPr>
-              <a:t>Athanase: net monthly returns, 235 months (2006–2025), real. PE real return ~8.6% committed basis (Phalippou, 2020); downside vol reported ~7% de-smoothed to ~13% (MSCI; Morningstar). Illustrative; past performance is not indicative of future results.</a:t>
+              <a:t>Athanase: net monthly returns, 235 months (2006–2025), real. PE realised ~11–14% (Cliffwater US state pensions 11.4%, 2000–22; BVCA UK/Europe 14.1%, 2001–23) vs headline IRR ~18–22%; downside vol reported ~7% de-smoothed to ~13% (MSCI; Morningstar). Illustrative; past performance ≠ future results.</a:t>
             </a:r>
           </a:p>
         </p:txBody>

</xml_diff>

<commit_message>
Use empirical de-smoothed PE volatility (~28% total; PIMCO/AQR) on total-vol axis: PE same vol as Athanase but levered downside vs Athanase upside
</commit_message>
<xml_diff>
--- a/Athanase_vs_Private_Equity.pptx
+++ b/Athanase_vs_Private_Equity.pptx
@@ -4110,7 +4110,7 @@
                 </a:solidFill>
                 <a:latin typeface="Arial"/>
               </a:rPr>
-              <a:t>On the honest numbers, Athanase out-returns real PE with more liquidity, lower fees and daily transparency.</a:t>
+              <a:t>On true risk, PE and Athanase carry similar volatility — but Athanase’s is mostly upside, and it returns more, with daily liquidity.</a:t>
             </a:r>
           </a:p>
         </p:txBody>
@@ -4176,7 +4176,7 @@
                 </a:solidFill>
                 <a:latin typeface="Arial"/>
               </a:rPr>
-              <a:t>Measured honestly, PE moves down and to the right — lower return, higher true risk — while Athanase sits up and to the left.</a:t>
+              <a:t>De-smoothed, PE’s ~10% reported vol is really ~28% (PIMCO; AQR beta 1.5–1.6) — about Athanase’s 27%, but levered downside, not upside.</a:t>
             </a:r>
           </a:p>
         </p:txBody>
@@ -4984,7 +4984,7 @@
                 </a:solidFill>
                 <a:latin typeface="Times New Roman"/>
               </a:rPr>
-              <a:t>Lower true downside</a:t>
+              <a:t>Similar vol, opposite shape</a:t>
             </a:r>
           </a:p>
         </p:txBody>
@@ -5026,7 +5026,7 @@
                 </a:solidFill>
                 <a:latin typeface="Arial"/>
               </a:rPr>
-              <a:t>De-smoothed, PE’s economic downside is ~13% vs Athanase’s ~11%.</a:t>
+              <a:t>PE’s true ~28% vol is levered downside; Athanase’s 27% is mostly upside (downside only ~11%).</a:t>
             </a:r>
           </a:p>
         </p:txBody>
@@ -5112,7 +5112,7 @@
                 </a:solidFill>
                 <a:latin typeface="Arial"/>
               </a:rPr>
-              <a:t>Switching a PE sleeve into Athanase keeps the operational upside but adds return, liquidity and transparency — once PE is measured the way you actually experience it.</a:t>
+              <a:t>Once PE’s smoothing is removed, the two carry similar volatility — but Athanase returns more, its risk is upside not downside, and it stays liquid and transparent.</a:t>
             </a:r>
           </a:p>
         </p:txBody>
@@ -5125,8 +5125,8 @@
         </p:nvSpPr>
         <p:spPr>
           <a:xfrm>
-            <a:off x="438922" y="6983577"/>
-            <a:ext cx="9217382" cy="409651"/>
+            <a:off x="438922" y="6944563"/>
+            <a:ext cx="9217382" cy="487680"/>
           </a:xfrm>
           <a:prstGeom prst="rect">
             <a:avLst/>
@@ -5154,7 +5154,7 @@
                 </a:solidFill>
                 <a:latin typeface="Arial"/>
               </a:rPr>
-              <a:t>Athanase: net monthly returns, 235 months (2006–2025), real. PE realised ~11–14% (Cliffwater US state pensions 11.4%, 2000–22; BVCA UK/Europe 14.1%, 2001–23) vs headline IRR ~18–22%; downside vol reported ~7% de-smoothed to ~13% (MSCI; Morningstar). Illustrative; past performance ≠ future results.</a:t>
+              <a:t>Athanase: net monthly returns, 235 months (2006–2025), real (total vol 27%, downside 11%). PE realised ~11–14% (Cliffwater 11.4%; BVCA 14.1%) vs headline IRR ~18–22%; reported ~10% vol de-smoothed to ~25–30% (PIMCO; AQR equity beta 1.5–1.6; Couts-Gonçalves-Rossi, 2024). Illustrative; past performance ≠ future results.</a:t>
             </a:r>
           </a:p>
         </p:txBody>

</xml_diff>

<commit_message>
Add academic-evidence slide: four de-smoothing methodologies converge on PE true vol ~2-3x reported (Ang/Boyer/Getmansky/Couts/Jackson)
</commit_message>
<xml_diff>
--- a/Athanase_vs_Private_Equity.pptx
+++ b/Athanase_vs_Private_Equity.pptx
@@ -7,6 +7,7 @@
   <p:sldIdLst>
     <p:sldId id="256" r:id="rId7"/>
     <p:sldId id="257" r:id="rId8"/>
+    <p:sldId id="258" r:id="rId9"/>
   </p:sldIdLst>
   <p:sldSz cx="9753600" cy="7315200" type="screen4x3"/>
   <p:notesSz cx="6858000" cy="9144000"/>
@@ -5155,6 +5156,924 @@
                 <a:latin typeface="Arial"/>
               </a:rPr>
               <a:t>Athanase: net monthly returns, 235 months (2006–2025), real (total vol 27%, downside 11%). PE realised ~11–14% (Cliffwater 11.4%; BVCA 14.1%) vs headline IRR ~18–22%; reported ~10% vol de-smoothed to ~25–30% (PIMCO; AQR equity beta 1.5–1.6; Couts-Gonçalves-Rossi, 2024). Illustrative; past performance ≠ future results.</a:t>
+            </a:r>
+          </a:p>
+        </p:txBody>
+      </p:sp>
+    </p:spTree>
+  </p:cSld>
+  <p:clrMapOvr>
+    <a:masterClrMapping/>
+  </p:clrMapOvr>
+</p:sld>
+</file>
+
+<file path=ppt/slides/slide3.xml><?xml version="1.0" encoding="utf-8"?>
+<p:sld xmlns:a="http://schemas.openxmlformats.org/drawingml/2006/main" xmlns:p="http://schemas.openxmlformats.org/presentationml/2006/main" xmlns:r="http://schemas.openxmlformats.org/officeDocument/2006/relationships">
+  <p:cSld>
+    <p:spTree>
+      <p:nvGrpSpPr>
+        <p:cNvPr id="1" name=""/>
+        <p:cNvGrpSpPr/>
+        <p:nvPr/>
+      </p:nvGrpSpPr>
+      <p:grpSpPr/>
+      <p:pic>
+        <p:nvPicPr>
+          <p:cNvPr id="2" name="Picture 1" descr="mark_dark.png"/>
+          <p:cNvPicPr>
+            <a:picLocks noChangeAspect="1"/>
+          </p:cNvPicPr>
+          <p:nvPr/>
+        </p:nvPicPr>
+        <p:blipFill>
+          <a:blip r:embed="rId2"/>
+          <a:stretch>
+            <a:fillRect/>
+          </a:stretch>
+        </p:blipFill>
+        <p:spPr>
+          <a:xfrm>
+            <a:off x="402346" y="234086"/>
+            <a:ext cx="224012" cy="190199"/>
+          </a:xfrm>
+          <a:prstGeom prst="rect">
+            <a:avLst/>
+          </a:prstGeom>
+        </p:spPr>
+      </p:pic>
+      <p:sp>
+        <p:nvSpPr>
+          <p:cNvPr id="3" name="TextBox 2"/>
+          <p:cNvSpPr txBox="1"/>
+          <p:nvPr/>
+        </p:nvSpPr>
+        <p:spPr>
+          <a:xfrm>
+            <a:off x="716907" y="263347"/>
+            <a:ext cx="5120768" cy="292608"/>
+          </a:xfrm>
+          <a:prstGeom prst="rect">
+            <a:avLst/>
+          </a:prstGeom>
+          <a:noFill/>
+        </p:spPr>
+        <p:txBody>
+          <a:bodyPr wrap="square" anchor="t" lIns="0" rIns="0" tIns="0" bIns="0">
+            <a:spAutoFit/>
+          </a:bodyPr>
+          <a:lstStyle/>
+          <a:p>
+            <a:pPr algn="l">
+              <a:lnSpc>
+                <a:spcPct val="110000"/>
+              </a:lnSpc>
+              <a:spcAft>
+                <a:spcPts val="0"/>
+              </a:spcAft>
+            </a:pPr>
+            <a:r>
+              <a:rPr sz="880" b="0" i="0">
+                <a:solidFill>
+                  <a:srgbClr val="556A83"/>
+                </a:solidFill>
+                <a:latin typeface="Arial"/>
+              </a:rPr>
+              <a:t>Risk-Adjusted Outcomes</a:t>
+            </a:r>
+          </a:p>
+        </p:txBody>
+      </p:sp>
+      <p:sp>
+        <p:nvSpPr>
+          <p:cNvPr id="4" name="TextBox 3"/>
+          <p:cNvSpPr txBox="1"/>
+          <p:nvPr/>
+        </p:nvSpPr>
+        <p:spPr>
+          <a:xfrm>
+            <a:off x="7242229" y="263347"/>
+            <a:ext cx="2084884" cy="292608"/>
+          </a:xfrm>
+          <a:prstGeom prst="rect">
+            <a:avLst/>
+          </a:prstGeom>
+          <a:noFill/>
+        </p:spPr>
+        <p:txBody>
+          <a:bodyPr wrap="square" anchor="t" lIns="0" rIns="0" tIns="0" bIns="0">
+            <a:spAutoFit/>
+          </a:bodyPr>
+          <a:lstStyle/>
+          <a:p>
+            <a:pPr algn="r">
+              <a:lnSpc>
+                <a:spcPct val="110000"/>
+              </a:lnSpc>
+              <a:spcAft>
+                <a:spcPts val="0"/>
+              </a:spcAft>
+            </a:pPr>
+            <a:r>
+              <a:rPr sz="880" b="1" i="0">
+                <a:solidFill>
+                  <a:srgbClr val="556A83"/>
+                </a:solidFill>
+                <a:latin typeface="Arial"/>
+              </a:rPr>
+              <a:t>Figure 3</a:t>
+            </a:r>
+          </a:p>
+        </p:txBody>
+      </p:sp>
+      <p:sp>
+        <p:nvSpPr>
+          <p:cNvPr id="5" name="Rectangle 4"/>
+          <p:cNvSpPr/>
+          <p:nvPr/>
+        </p:nvSpPr>
+        <p:spPr>
+          <a:xfrm>
+            <a:off x="0" y="604723"/>
+            <a:ext cx="9753600" cy="1414272"/>
+          </a:xfrm>
+          <a:prstGeom prst="rect">
+            <a:avLst/>
+          </a:prstGeom>
+          <a:solidFill>
+            <a:srgbClr val="F6F7F9"/>
+          </a:solidFill>
+          <a:ln>
+            <a:noFill/>
+          </a:ln>
+          <a:effectLst/>
+        </p:spPr>
+        <p:style>
+          <a:lnRef idx="1">
+            <a:schemeClr val="accent1"/>
+          </a:lnRef>
+          <a:fillRef idx="3">
+            <a:schemeClr val="accent1"/>
+          </a:fillRef>
+          <a:effectRef idx="2">
+            <a:schemeClr val="accent1"/>
+          </a:effectRef>
+          <a:fontRef idx="minor">
+            <a:schemeClr val="lt1"/>
+          </a:fontRef>
+        </p:style>
+        <p:txBody>
+          <a:bodyPr rtlCol="0" anchor="ctr"/>
+          <a:lstStyle/>
+          <a:p>
+            <a:pPr algn="ctr"/>
+          </a:p>
+        </p:txBody>
+      </p:sp>
+      <p:sp>
+        <p:nvSpPr>
+          <p:cNvPr id="6" name="TextBox 5"/>
+          <p:cNvSpPr txBox="1"/>
+          <p:nvPr/>
+        </p:nvSpPr>
+        <p:spPr>
+          <a:xfrm>
+            <a:off x="438922" y="721766"/>
+            <a:ext cx="8851613" cy="829056"/>
+          </a:xfrm>
+          <a:prstGeom prst="rect">
+            <a:avLst/>
+          </a:prstGeom>
+          <a:noFill/>
+        </p:spPr>
+        <p:txBody>
+          <a:bodyPr wrap="square" anchor="t" lIns="0" rIns="0" tIns="0" bIns="0">
+            <a:spAutoFit/>
+          </a:bodyPr>
+          <a:lstStyle/>
+          <a:p>
+            <a:pPr algn="l">
+              <a:lnSpc>
+                <a:spcPct val="110000"/>
+              </a:lnSpc>
+              <a:spcAft>
+                <a:spcPts val="200"/>
+              </a:spcAft>
+            </a:pPr>
+            <a:r>
+              <a:rPr sz="2400" b="0" i="0">
+                <a:solidFill>
+                  <a:srgbClr val="314359"/>
+                </a:solidFill>
+                <a:latin typeface="Times New Roman"/>
+              </a:rPr>
+              <a:t>The volatility gap is settled in the literature</a:t>
+            </a:r>
+          </a:p>
+        </p:txBody>
+      </p:sp>
+      <p:sp>
+        <p:nvSpPr>
+          <p:cNvPr id="7" name="TextBox 6"/>
+          <p:cNvSpPr txBox="1"/>
+          <p:nvPr/>
+        </p:nvSpPr>
+        <p:spPr>
+          <a:xfrm>
+            <a:off x="453553" y="1511808"/>
+            <a:ext cx="8705305" cy="487680"/>
+          </a:xfrm>
+          <a:prstGeom prst="rect">
+            <a:avLst/>
+          </a:prstGeom>
+          <a:noFill/>
+        </p:spPr>
+        <p:txBody>
+          <a:bodyPr wrap="square" anchor="t" lIns="0" rIns="0" tIns="0" bIns="0">
+            <a:spAutoFit/>
+          </a:bodyPr>
+          <a:lstStyle/>
+          <a:p>
+            <a:pPr algn="l">
+              <a:lnSpc>
+                <a:spcPct val="110000"/>
+              </a:lnSpc>
+              <a:spcAft>
+                <a:spcPts val="0"/>
+              </a:spcAft>
+            </a:pPr>
+            <a:r>
+              <a:rPr sz="1040" b="0" i="1">
+                <a:solidFill>
+                  <a:srgbClr val="556A83"/>
+                </a:solidFill>
+                <a:latin typeface="Arial"/>
+              </a:rPr>
+              <a:t>Cash-flow models, secondary-market prices and econometric unsmoothing all converge: PE’s true risk is roughly 2–3× its reported figure.</a:t>
+            </a:r>
+          </a:p>
+        </p:txBody>
+      </p:sp>
+      <p:pic>
+        <p:nvPicPr>
+          <p:cNvPr id="8" name="Picture 7" descr="pe_evidence.png"/>
+          <p:cNvPicPr>
+            <a:picLocks noChangeAspect="1"/>
+          </p:cNvPicPr>
+          <p:nvPr/>
+        </p:nvPicPr>
+        <p:blipFill>
+          <a:blip r:embed="rId3"/>
+          <a:stretch>
+            <a:fillRect/>
+          </a:stretch>
+        </p:blipFill>
+        <p:spPr>
+          <a:xfrm>
+            <a:off x="365769" y="2194560"/>
+            <a:ext cx="4957136" cy="2962730"/>
+          </a:xfrm>
+          <a:prstGeom prst="rect">
+            <a:avLst/>
+          </a:prstGeom>
+        </p:spPr>
+      </p:pic>
+      <p:sp>
+        <p:nvSpPr>
+          <p:cNvPr id="9" name="Rectangle 8"/>
+          <p:cNvSpPr/>
+          <p:nvPr/>
+        </p:nvSpPr>
+        <p:spPr>
+          <a:xfrm>
+            <a:off x="6218075" y="2243328"/>
+            <a:ext cx="3109037" cy="897331"/>
+          </a:xfrm>
+          <a:prstGeom prst="rect">
+            <a:avLst/>
+          </a:prstGeom>
+          <a:solidFill>
+            <a:srgbClr val="F6F7F9"/>
+          </a:solidFill>
+          <a:ln>
+            <a:noFill/>
+          </a:ln>
+          <a:effectLst/>
+        </p:spPr>
+        <p:style>
+          <a:lnRef idx="1">
+            <a:schemeClr val="accent1"/>
+          </a:lnRef>
+          <a:fillRef idx="3">
+            <a:schemeClr val="accent1"/>
+          </a:fillRef>
+          <a:effectRef idx="2">
+            <a:schemeClr val="accent1"/>
+          </a:effectRef>
+          <a:fontRef idx="minor">
+            <a:schemeClr val="lt1"/>
+          </a:fontRef>
+        </p:style>
+        <p:txBody>
+          <a:bodyPr rtlCol="0" anchor="ctr"/>
+          <a:lstStyle/>
+          <a:p>
+            <a:pPr algn="ctr"/>
+          </a:p>
+        </p:txBody>
+      </p:sp>
+      <p:sp>
+        <p:nvSpPr>
+          <p:cNvPr id="10" name="TextBox 9"/>
+          <p:cNvSpPr txBox="1"/>
+          <p:nvPr/>
+        </p:nvSpPr>
+        <p:spPr>
+          <a:xfrm>
+            <a:off x="6364383" y="2340864"/>
+            <a:ext cx="2816422" cy="243840"/>
+          </a:xfrm>
+          <a:prstGeom prst="rect">
+            <a:avLst/>
+          </a:prstGeom>
+          <a:noFill/>
+        </p:spPr>
+        <p:txBody>
+          <a:bodyPr wrap="square" anchor="t" lIns="0" rIns="0" tIns="0" bIns="0">
+            <a:spAutoFit/>
+          </a:bodyPr>
+          <a:lstStyle/>
+          <a:p>
+            <a:pPr algn="l">
+              <a:lnSpc>
+                <a:spcPct val="110000"/>
+              </a:lnSpc>
+              <a:spcAft>
+                <a:spcPts val="0"/>
+              </a:spcAft>
+            </a:pPr>
+            <a:r>
+              <a:rPr sz="800" b="1" i="0">
+                <a:solidFill>
+                  <a:srgbClr val="314359"/>
+                </a:solidFill>
+                <a:latin typeface="Arial"/>
+              </a:rPr>
+              <a:t>CASH-FLOW NPV MODEL</a:t>
+            </a:r>
+          </a:p>
+        </p:txBody>
+      </p:sp>
+      <p:sp>
+        <p:nvSpPr>
+          <p:cNvPr id="11" name="TextBox 10"/>
+          <p:cNvSpPr txBox="1"/>
+          <p:nvPr/>
+        </p:nvSpPr>
+        <p:spPr>
+          <a:xfrm>
+            <a:off x="6364383" y="2574950"/>
+            <a:ext cx="2816422" cy="536448"/>
+          </a:xfrm>
+          <a:prstGeom prst="rect">
+            <a:avLst/>
+          </a:prstGeom>
+          <a:noFill/>
+        </p:spPr>
+        <p:txBody>
+          <a:bodyPr wrap="square" anchor="t" lIns="0" rIns="0" tIns="0" bIns="0">
+            <a:spAutoFit/>
+          </a:bodyPr>
+          <a:lstStyle/>
+          <a:p>
+            <a:pPr algn="l">
+              <a:lnSpc>
+                <a:spcPct val="112000"/>
+              </a:lnSpc>
+              <a:spcAft>
+                <a:spcPts val="0"/>
+              </a:spcAft>
+            </a:pPr>
+            <a:r>
+              <a:rPr sz="760" b="0" i="0">
+                <a:solidFill>
+                  <a:srgbClr val="0E1620"/>
+                </a:solidFill>
+                <a:latin typeface="Arial"/>
+              </a:rPr>
+              <a:t>Buyout vol 25% (vs 11% index), beta &gt; 1 — Ang, Chen, Goetzmann &amp; Phalippou (2018), J. Finance.</a:t>
+            </a:r>
+          </a:p>
+        </p:txBody>
+      </p:sp>
+      <p:sp>
+        <p:nvSpPr>
+          <p:cNvPr id="12" name="Rectangle 11"/>
+          <p:cNvSpPr/>
+          <p:nvPr/>
+        </p:nvSpPr>
+        <p:spPr>
+          <a:xfrm>
+            <a:off x="6218075" y="3257702"/>
+            <a:ext cx="3109037" cy="897331"/>
+          </a:xfrm>
+          <a:prstGeom prst="rect">
+            <a:avLst/>
+          </a:prstGeom>
+          <a:solidFill>
+            <a:srgbClr val="F6F7F9"/>
+          </a:solidFill>
+          <a:ln>
+            <a:noFill/>
+          </a:ln>
+          <a:effectLst/>
+        </p:spPr>
+        <p:style>
+          <a:lnRef idx="1">
+            <a:schemeClr val="accent1"/>
+          </a:lnRef>
+          <a:fillRef idx="3">
+            <a:schemeClr val="accent1"/>
+          </a:fillRef>
+          <a:effectRef idx="2">
+            <a:schemeClr val="accent1"/>
+          </a:effectRef>
+          <a:fontRef idx="minor">
+            <a:schemeClr val="lt1"/>
+          </a:fontRef>
+        </p:style>
+        <p:txBody>
+          <a:bodyPr rtlCol="0" anchor="ctr"/>
+          <a:lstStyle/>
+          <a:p>
+            <a:pPr algn="ctr"/>
+          </a:p>
+        </p:txBody>
+      </p:sp>
+      <p:sp>
+        <p:nvSpPr>
+          <p:cNvPr id="13" name="TextBox 12"/>
+          <p:cNvSpPr txBox="1"/>
+          <p:nvPr/>
+        </p:nvSpPr>
+        <p:spPr>
+          <a:xfrm>
+            <a:off x="6364383" y="3355238"/>
+            <a:ext cx="2816422" cy="243840"/>
+          </a:xfrm>
+          <a:prstGeom prst="rect">
+            <a:avLst/>
+          </a:prstGeom>
+          <a:noFill/>
+        </p:spPr>
+        <p:txBody>
+          <a:bodyPr wrap="square" anchor="t" lIns="0" rIns="0" tIns="0" bIns="0">
+            <a:spAutoFit/>
+          </a:bodyPr>
+          <a:lstStyle/>
+          <a:p>
+            <a:pPr algn="l">
+              <a:lnSpc>
+                <a:spcPct val="110000"/>
+              </a:lnSpc>
+              <a:spcAft>
+                <a:spcPts val="0"/>
+              </a:spcAft>
+            </a:pPr>
+            <a:r>
+              <a:rPr sz="800" b="1" i="0">
+                <a:solidFill>
+                  <a:srgbClr val="314359"/>
+                </a:solidFill>
+                <a:latin typeface="Arial"/>
+              </a:rPr>
+              <a:t>SECONDARY-MARKET PRICES</a:t>
+            </a:r>
+          </a:p>
+        </p:txBody>
+      </p:sp>
+      <p:sp>
+        <p:nvSpPr>
+          <p:cNvPr id="14" name="TextBox 13"/>
+          <p:cNvSpPr txBox="1"/>
+          <p:nvPr/>
+        </p:nvSpPr>
+        <p:spPr>
+          <a:xfrm>
+            <a:off x="6364383" y="3589324"/>
+            <a:ext cx="2816422" cy="536448"/>
+          </a:xfrm>
+          <a:prstGeom prst="rect">
+            <a:avLst/>
+          </a:prstGeom>
+          <a:noFill/>
+        </p:spPr>
+        <p:txBody>
+          <a:bodyPr wrap="square" anchor="t" lIns="0" rIns="0" tIns="0" bIns="0">
+            <a:spAutoFit/>
+          </a:bodyPr>
+          <a:lstStyle/>
+          <a:p>
+            <a:pPr algn="l">
+              <a:lnSpc>
+                <a:spcPct val="112000"/>
+              </a:lnSpc>
+              <a:spcAft>
+                <a:spcPts val="0"/>
+              </a:spcAft>
+            </a:pPr>
+            <a:r>
+              <a:rPr sz="760" b="0" i="0">
+                <a:solidFill>
+                  <a:srgbClr val="0E1620"/>
+                </a:solidFill>
+                <a:latin typeface="Arial"/>
+              </a:rPr>
+              <a:t>Traded-stake beta &gt; 2.0 vs &lt; 0.5 for the same firms on NAV — Boyer, Nadauld, Vorkink &amp; Weisbach (2018).</a:t>
+            </a:r>
+          </a:p>
+        </p:txBody>
+      </p:sp>
+      <p:sp>
+        <p:nvSpPr>
+          <p:cNvPr id="15" name="Rectangle 14"/>
+          <p:cNvSpPr/>
+          <p:nvPr/>
+        </p:nvSpPr>
+        <p:spPr>
+          <a:xfrm>
+            <a:off x="6218075" y="4272076"/>
+            <a:ext cx="3109037" cy="897331"/>
+          </a:xfrm>
+          <a:prstGeom prst="rect">
+            <a:avLst/>
+          </a:prstGeom>
+          <a:solidFill>
+            <a:srgbClr val="F6F7F9"/>
+          </a:solidFill>
+          <a:ln>
+            <a:noFill/>
+          </a:ln>
+          <a:effectLst/>
+        </p:spPr>
+        <p:style>
+          <a:lnRef idx="1">
+            <a:schemeClr val="accent1"/>
+          </a:lnRef>
+          <a:fillRef idx="3">
+            <a:schemeClr val="accent1"/>
+          </a:fillRef>
+          <a:effectRef idx="2">
+            <a:schemeClr val="accent1"/>
+          </a:effectRef>
+          <a:fontRef idx="minor">
+            <a:schemeClr val="lt1"/>
+          </a:fontRef>
+        </p:style>
+        <p:txBody>
+          <a:bodyPr rtlCol="0" anchor="ctr"/>
+          <a:lstStyle/>
+          <a:p>
+            <a:pPr algn="ctr"/>
+          </a:p>
+        </p:txBody>
+      </p:sp>
+      <p:sp>
+        <p:nvSpPr>
+          <p:cNvPr id="16" name="TextBox 15"/>
+          <p:cNvSpPr txBox="1"/>
+          <p:nvPr/>
+        </p:nvSpPr>
+        <p:spPr>
+          <a:xfrm>
+            <a:off x="6364383" y="4369612"/>
+            <a:ext cx="2816422" cy="243840"/>
+          </a:xfrm>
+          <a:prstGeom prst="rect">
+            <a:avLst/>
+          </a:prstGeom>
+          <a:noFill/>
+        </p:spPr>
+        <p:txBody>
+          <a:bodyPr wrap="square" anchor="t" lIns="0" rIns="0" tIns="0" bIns="0">
+            <a:spAutoFit/>
+          </a:bodyPr>
+          <a:lstStyle/>
+          <a:p>
+            <a:pPr algn="l">
+              <a:lnSpc>
+                <a:spcPct val="110000"/>
+              </a:lnSpc>
+              <a:spcAft>
+                <a:spcPts val="0"/>
+              </a:spcAft>
+            </a:pPr>
+            <a:r>
+              <a:rPr sz="800" b="1" i="0">
+                <a:solidFill>
+                  <a:srgbClr val="314359"/>
+                </a:solidFill>
+                <a:latin typeface="Arial"/>
+              </a:rPr>
+              <a:t>ECONOMETRIC UNSMOOTHING</a:t>
+            </a:r>
+          </a:p>
+        </p:txBody>
+      </p:sp>
+      <p:sp>
+        <p:nvSpPr>
+          <p:cNvPr id="17" name="TextBox 16"/>
+          <p:cNvSpPr txBox="1"/>
+          <p:nvPr/>
+        </p:nvSpPr>
+        <p:spPr>
+          <a:xfrm>
+            <a:off x="6364383" y="4603699"/>
+            <a:ext cx="2816422" cy="536448"/>
+          </a:xfrm>
+          <a:prstGeom prst="rect">
+            <a:avLst/>
+          </a:prstGeom>
+          <a:noFill/>
+        </p:spPr>
+        <p:txBody>
+          <a:bodyPr wrap="square" anchor="t" lIns="0" rIns="0" tIns="0" bIns="0">
+            <a:spAutoFit/>
+          </a:bodyPr>
+          <a:lstStyle/>
+          <a:p>
+            <a:pPr algn="l">
+              <a:lnSpc>
+                <a:spcPct val="112000"/>
+              </a:lnSpc>
+              <a:spcAft>
+                <a:spcPts val="0"/>
+              </a:spcAft>
+            </a:pPr>
+            <a:r>
+              <a:rPr sz="760" b="0" i="0">
+                <a:solidFill>
+                  <a:srgbClr val="0E1620"/>
+                </a:solidFill>
+                <a:latin typeface="Arial"/>
+              </a:rPr>
+              <a:t>Illiquidity creates spurious smoothness that suppresses vol — Getmansky, Lo &amp; Makarov (2004), JFE (cited 1,300+).</a:t>
+            </a:r>
+          </a:p>
+        </p:txBody>
+      </p:sp>
+      <p:sp>
+        <p:nvSpPr>
+          <p:cNvPr id="18" name="Rectangle 17"/>
+          <p:cNvSpPr/>
+          <p:nvPr/>
+        </p:nvSpPr>
+        <p:spPr>
+          <a:xfrm>
+            <a:off x="6218075" y="5286451"/>
+            <a:ext cx="3109037" cy="897331"/>
+          </a:xfrm>
+          <a:prstGeom prst="rect">
+            <a:avLst/>
+          </a:prstGeom>
+          <a:solidFill>
+            <a:srgbClr val="F6F7F9"/>
+          </a:solidFill>
+          <a:ln>
+            <a:noFill/>
+          </a:ln>
+          <a:effectLst/>
+        </p:spPr>
+        <p:style>
+          <a:lnRef idx="1">
+            <a:schemeClr val="accent1"/>
+          </a:lnRef>
+          <a:fillRef idx="3">
+            <a:schemeClr val="accent1"/>
+          </a:fillRef>
+          <a:effectRef idx="2">
+            <a:schemeClr val="accent1"/>
+          </a:effectRef>
+          <a:fontRef idx="minor">
+            <a:schemeClr val="lt1"/>
+          </a:fontRef>
+        </p:style>
+        <p:txBody>
+          <a:bodyPr rtlCol="0" anchor="ctr"/>
+          <a:lstStyle/>
+          <a:p>
+            <a:pPr algn="ctr"/>
+          </a:p>
+        </p:txBody>
+      </p:sp>
+      <p:sp>
+        <p:nvSpPr>
+          <p:cNvPr id="19" name="TextBox 18"/>
+          <p:cNvSpPr txBox="1"/>
+          <p:nvPr/>
+        </p:nvSpPr>
+        <p:spPr>
+          <a:xfrm>
+            <a:off x="6364383" y="5383987"/>
+            <a:ext cx="2816422" cy="243840"/>
+          </a:xfrm>
+          <a:prstGeom prst="rect">
+            <a:avLst/>
+          </a:prstGeom>
+          <a:noFill/>
+        </p:spPr>
+        <p:txBody>
+          <a:bodyPr wrap="square" anchor="t" lIns="0" rIns="0" tIns="0" bIns="0">
+            <a:spAutoFit/>
+          </a:bodyPr>
+          <a:lstStyle/>
+          <a:p>
+            <a:pPr algn="l">
+              <a:lnSpc>
+                <a:spcPct val="110000"/>
+              </a:lnSpc>
+              <a:spcAft>
+                <a:spcPts val="0"/>
+              </a:spcAft>
+            </a:pPr>
+            <a:r>
+              <a:rPr sz="800" b="1" i="0">
+                <a:solidFill>
+                  <a:srgbClr val="314359"/>
+                </a:solidFill>
+                <a:latin typeface="Arial"/>
+              </a:rPr>
+              <a:t>CATERING / “LAUNDERING”</a:t>
+            </a:r>
+          </a:p>
+        </p:txBody>
+      </p:sp>
+      <p:sp>
+        <p:nvSpPr>
+          <p:cNvPr id="20" name="TextBox 19"/>
+          <p:cNvSpPr txBox="1"/>
+          <p:nvPr/>
+        </p:nvSpPr>
+        <p:spPr>
+          <a:xfrm>
+            <a:off x="6364383" y="5618073"/>
+            <a:ext cx="2816422" cy="536448"/>
+          </a:xfrm>
+          <a:prstGeom prst="rect">
+            <a:avLst/>
+          </a:prstGeom>
+          <a:noFill/>
+        </p:spPr>
+        <p:txBody>
+          <a:bodyPr wrap="square" anchor="t" lIns="0" rIns="0" tIns="0" bIns="0">
+            <a:spAutoFit/>
+          </a:bodyPr>
+          <a:lstStyle/>
+          <a:p>
+            <a:pPr algn="l">
+              <a:lnSpc>
+                <a:spcPct val="112000"/>
+              </a:lnSpc>
+              <a:spcAft>
+                <a:spcPts val="0"/>
+              </a:spcAft>
+            </a:pPr>
+            <a:r>
+              <a:rPr sz="760" b="0" i="0">
+                <a:solidFill>
+                  <a:srgbClr val="0E1620"/>
+                </a:solidFill>
+                <a:latin typeface="Arial"/>
+              </a:rPr>
+              <a:t>GPs smooth returns because LPs value the “phony happiness” — Jackson, Ling &amp; Naranjo (2022); Couts et al. (2020).</a:t>
+            </a:r>
+          </a:p>
+        </p:txBody>
+      </p:sp>
+      <p:sp>
+        <p:nvSpPr>
+          <p:cNvPr id="21" name="Rectangle 20"/>
+          <p:cNvSpPr/>
+          <p:nvPr/>
+        </p:nvSpPr>
+        <p:spPr>
+          <a:xfrm>
+            <a:off x="438922" y="6456883"/>
+            <a:ext cx="8873559" cy="448665"/>
+          </a:xfrm>
+          <a:prstGeom prst="rect">
+            <a:avLst/>
+          </a:prstGeom>
+          <a:solidFill>
+            <a:srgbClr val="152130"/>
+          </a:solidFill>
+          <a:ln>
+            <a:noFill/>
+          </a:ln>
+          <a:effectLst/>
+        </p:spPr>
+        <p:style>
+          <a:lnRef idx="1">
+            <a:schemeClr val="accent1"/>
+          </a:lnRef>
+          <a:fillRef idx="3">
+            <a:schemeClr val="accent1"/>
+          </a:fillRef>
+          <a:effectRef idx="2">
+            <a:schemeClr val="accent1"/>
+          </a:effectRef>
+          <a:fontRef idx="minor">
+            <a:schemeClr val="lt1"/>
+          </a:fontRef>
+        </p:style>
+        <p:txBody>
+          <a:bodyPr rtlCol="0" anchor="ctr"/>
+          <a:lstStyle/>
+          <a:p>
+            <a:pPr algn="ctr"/>
+          </a:p>
+        </p:txBody>
+      </p:sp>
+      <p:sp>
+        <p:nvSpPr>
+          <p:cNvPr id="22" name="TextBox 21"/>
+          <p:cNvSpPr txBox="1"/>
+          <p:nvPr/>
+        </p:nvSpPr>
+        <p:spPr>
+          <a:xfrm>
+            <a:off x="570599" y="6456883"/>
+            <a:ext cx="8632151" cy="448665"/>
+          </a:xfrm>
+          <a:prstGeom prst="rect">
+            <a:avLst/>
+          </a:prstGeom>
+          <a:noFill/>
+        </p:spPr>
+        <p:txBody>
+          <a:bodyPr wrap="square" anchor="ctr" lIns="0" rIns="0" tIns="0" bIns="0">
+            <a:spAutoFit/>
+          </a:bodyPr>
+          <a:lstStyle/>
+          <a:p>
+            <a:pPr algn="l">
+              <a:lnSpc>
+                <a:spcPct val="110000"/>
+              </a:lnSpc>
+              <a:spcAft>
+                <a:spcPts val="0"/>
+              </a:spcAft>
+            </a:pPr>
+            <a:r>
+              <a:rPr sz="960" b="0" i="1">
+                <a:solidFill>
+                  <a:srgbClr val="FFFFFF"/>
+                </a:solidFill>
+                <a:latin typeface="Arial"/>
+              </a:rPr>
+              <a:t>Independent methods, the same answer: PE is a highly-levered equity portfolio whose reported smoothness is an artefact — its true volatility rivals Athanase’s, without the upside skew.</a:t>
+            </a:r>
+          </a:p>
+        </p:txBody>
+      </p:sp>
+      <p:sp>
+        <p:nvSpPr>
+          <p:cNvPr id="23" name="TextBox 22"/>
+          <p:cNvSpPr txBox="1"/>
+          <p:nvPr/>
+        </p:nvSpPr>
+        <p:spPr>
+          <a:xfrm>
+            <a:off x="438922" y="6944563"/>
+            <a:ext cx="9217382" cy="487680"/>
+          </a:xfrm>
+          <a:prstGeom prst="rect">
+            <a:avLst/>
+          </a:prstGeom>
+          <a:noFill/>
+        </p:spPr>
+        <p:txBody>
+          <a:bodyPr wrap="square" anchor="t" lIns="0" rIns="0" tIns="0" bIns="0">
+            <a:spAutoFit/>
+          </a:bodyPr>
+          <a:lstStyle/>
+          <a:p>
+            <a:pPr algn="l">
+              <a:lnSpc>
+                <a:spcPct val="110000"/>
+              </a:lnSpc>
+              <a:spcAft>
+                <a:spcPts val="0"/>
+              </a:spcAft>
+            </a:pPr>
+            <a:r>
+              <a:rPr sz="560" b="0" i="0">
+                <a:solidFill>
+                  <a:srgbClr val="556A83"/>
+                </a:solidFill>
+                <a:latin typeface="Arial"/>
+              </a:rPr>
+              <a:t>Sources: Ang, Chen, Goetzmann &amp; Phalippou (2018, J. Finance 73(4)); Boyer, Nadauld, Vorkink &amp; Weisbach (2018); Getmansky, Lo &amp; Makarov (2004, JFE 74(3)); Couts, Gonçalves &amp; Rossi (2020); Jackson, Ling &amp; Naranjo (2022); PIMCO (2022); AQR (Asness). Bars show vol-equivalent risk; beta rows scaled for comparison. Illustrative.</a:t>
             </a:r>
           </a:p>
         </p:txBody>

</xml_diff>

<commit_message>
Add lower-real-risk slide: same total vol but Athanase downside ~11% vs PE ~20%; 30% loss prob ~2% vs PE ~16% (PIMCO)
</commit_message>
<xml_diff>
--- a/Athanase_vs_Private_Equity.pptx
+++ b/Athanase_vs_Private_Equity.pptx
@@ -8,6 +8,7 @@
     <p:sldId id="256" r:id="rId7"/>
     <p:sldId id="257" r:id="rId8"/>
     <p:sldId id="258" r:id="rId9"/>
+    <p:sldId id="259" r:id="rId10"/>
   </p:sldIdLst>
   <p:sldSz cx="9753600" cy="7315200" type="screen4x3"/>
   <p:notesSz cx="6858000" cy="9144000"/>
@@ -6074,6 +6075,822 @@
                 <a:latin typeface="Arial"/>
               </a:rPr>
               <a:t>Sources: Ang, Chen, Goetzmann &amp; Phalippou (2018, J. Finance 73(4)); Boyer, Nadauld, Vorkink &amp; Weisbach (2018); Getmansky, Lo &amp; Makarov (2004, JFE 74(3)); Couts, Gonçalves &amp; Rossi (2020); Jackson, Ling &amp; Naranjo (2022); PIMCO (2022); AQR (Asness). Bars show vol-equivalent risk; beta rows scaled for comparison. Illustrative.</a:t>
+            </a:r>
+          </a:p>
+        </p:txBody>
+      </p:sp>
+    </p:spTree>
+  </p:cSld>
+  <p:clrMapOvr>
+    <a:masterClrMapping/>
+  </p:clrMapOvr>
+</p:sld>
+</file>
+
+<file path=ppt/slides/slide4.xml><?xml version="1.0" encoding="utf-8"?>
+<p:sld xmlns:a="http://schemas.openxmlformats.org/drawingml/2006/main" xmlns:p="http://schemas.openxmlformats.org/presentationml/2006/main" xmlns:r="http://schemas.openxmlformats.org/officeDocument/2006/relationships">
+  <p:cSld>
+    <p:spTree>
+      <p:nvGrpSpPr>
+        <p:cNvPr id="1" name=""/>
+        <p:cNvGrpSpPr/>
+        <p:nvPr/>
+      </p:nvGrpSpPr>
+      <p:grpSpPr/>
+      <p:pic>
+        <p:nvPicPr>
+          <p:cNvPr id="2" name="Picture 1" descr="mark_dark.png"/>
+          <p:cNvPicPr>
+            <a:picLocks noChangeAspect="1"/>
+          </p:cNvPicPr>
+          <p:nvPr/>
+        </p:nvPicPr>
+        <p:blipFill>
+          <a:blip r:embed="rId2"/>
+          <a:stretch>
+            <a:fillRect/>
+          </a:stretch>
+        </p:blipFill>
+        <p:spPr>
+          <a:xfrm>
+            <a:off x="402346" y="234086"/>
+            <a:ext cx="224012" cy="190199"/>
+          </a:xfrm>
+          <a:prstGeom prst="rect">
+            <a:avLst/>
+          </a:prstGeom>
+        </p:spPr>
+      </p:pic>
+      <p:sp>
+        <p:nvSpPr>
+          <p:cNvPr id="3" name="TextBox 2"/>
+          <p:cNvSpPr txBox="1"/>
+          <p:nvPr/>
+        </p:nvSpPr>
+        <p:spPr>
+          <a:xfrm>
+            <a:off x="716907" y="263347"/>
+            <a:ext cx="5120768" cy="292608"/>
+          </a:xfrm>
+          <a:prstGeom prst="rect">
+            <a:avLst/>
+          </a:prstGeom>
+          <a:noFill/>
+        </p:spPr>
+        <p:txBody>
+          <a:bodyPr wrap="square" anchor="t" lIns="0" rIns="0" tIns="0" bIns="0">
+            <a:spAutoFit/>
+          </a:bodyPr>
+          <a:lstStyle/>
+          <a:p>
+            <a:pPr algn="l">
+              <a:lnSpc>
+                <a:spcPct val="110000"/>
+              </a:lnSpc>
+              <a:spcAft>
+                <a:spcPts val="0"/>
+              </a:spcAft>
+            </a:pPr>
+            <a:r>
+              <a:rPr sz="880" b="0" i="0">
+                <a:solidFill>
+                  <a:srgbClr val="556A83"/>
+                </a:solidFill>
+                <a:latin typeface="Arial"/>
+              </a:rPr>
+              <a:t>Risk-Adjusted Outcomes</a:t>
+            </a:r>
+          </a:p>
+        </p:txBody>
+      </p:sp>
+      <p:sp>
+        <p:nvSpPr>
+          <p:cNvPr id="4" name="TextBox 3"/>
+          <p:cNvSpPr txBox="1"/>
+          <p:nvPr/>
+        </p:nvSpPr>
+        <p:spPr>
+          <a:xfrm>
+            <a:off x="7242229" y="263347"/>
+            <a:ext cx="2084884" cy="292608"/>
+          </a:xfrm>
+          <a:prstGeom prst="rect">
+            <a:avLst/>
+          </a:prstGeom>
+          <a:noFill/>
+        </p:spPr>
+        <p:txBody>
+          <a:bodyPr wrap="square" anchor="t" lIns="0" rIns="0" tIns="0" bIns="0">
+            <a:spAutoFit/>
+          </a:bodyPr>
+          <a:lstStyle/>
+          <a:p>
+            <a:pPr algn="r">
+              <a:lnSpc>
+                <a:spcPct val="110000"/>
+              </a:lnSpc>
+              <a:spcAft>
+                <a:spcPts val="0"/>
+              </a:spcAft>
+            </a:pPr>
+            <a:r>
+              <a:rPr sz="880" b="1" i="0">
+                <a:solidFill>
+                  <a:srgbClr val="556A83"/>
+                </a:solidFill>
+                <a:latin typeface="Arial"/>
+              </a:rPr>
+              <a:t>Figure 4</a:t>
+            </a:r>
+          </a:p>
+        </p:txBody>
+      </p:sp>
+      <p:sp>
+        <p:nvSpPr>
+          <p:cNvPr id="5" name="Rectangle 4"/>
+          <p:cNvSpPr/>
+          <p:nvPr/>
+        </p:nvSpPr>
+        <p:spPr>
+          <a:xfrm>
+            <a:off x="0" y="604723"/>
+            <a:ext cx="9753600" cy="1414272"/>
+          </a:xfrm>
+          <a:prstGeom prst="rect">
+            <a:avLst/>
+          </a:prstGeom>
+          <a:solidFill>
+            <a:srgbClr val="F6F7F9"/>
+          </a:solidFill>
+          <a:ln>
+            <a:noFill/>
+          </a:ln>
+          <a:effectLst/>
+        </p:spPr>
+        <p:style>
+          <a:lnRef idx="1">
+            <a:schemeClr val="accent1"/>
+          </a:lnRef>
+          <a:fillRef idx="3">
+            <a:schemeClr val="accent1"/>
+          </a:fillRef>
+          <a:effectRef idx="2">
+            <a:schemeClr val="accent1"/>
+          </a:effectRef>
+          <a:fontRef idx="minor">
+            <a:schemeClr val="lt1"/>
+          </a:fontRef>
+        </p:style>
+        <p:txBody>
+          <a:bodyPr rtlCol="0" anchor="ctr"/>
+          <a:lstStyle/>
+          <a:p>
+            <a:pPr algn="ctr"/>
+          </a:p>
+        </p:txBody>
+      </p:sp>
+      <p:sp>
+        <p:nvSpPr>
+          <p:cNvPr id="6" name="TextBox 5"/>
+          <p:cNvSpPr txBox="1"/>
+          <p:nvPr/>
+        </p:nvSpPr>
+        <p:spPr>
+          <a:xfrm>
+            <a:off x="438922" y="721766"/>
+            <a:ext cx="8851613" cy="829056"/>
+          </a:xfrm>
+          <a:prstGeom prst="rect">
+            <a:avLst/>
+          </a:prstGeom>
+          <a:noFill/>
+        </p:spPr>
+        <p:txBody>
+          <a:bodyPr wrap="square" anchor="t" lIns="0" rIns="0" tIns="0" bIns="0">
+            <a:spAutoFit/>
+          </a:bodyPr>
+          <a:lstStyle/>
+          <a:p>
+            <a:pPr algn="l">
+              <a:lnSpc>
+                <a:spcPct val="110000"/>
+              </a:lnSpc>
+              <a:spcAft>
+                <a:spcPts val="200"/>
+              </a:spcAft>
+            </a:pPr>
+            <a:r>
+              <a:rPr sz="2400" b="0" i="0">
+                <a:solidFill>
+                  <a:srgbClr val="314359"/>
+                </a:solidFill>
+                <a:latin typeface="Times New Roman"/>
+              </a:rPr>
+              <a:t>Same headline volatility — far lower real risk</a:t>
+            </a:r>
+          </a:p>
+        </p:txBody>
+      </p:sp>
+      <p:sp>
+        <p:nvSpPr>
+          <p:cNvPr id="7" name="TextBox 6"/>
+          <p:cNvSpPr txBox="1"/>
+          <p:nvPr/>
+        </p:nvSpPr>
+        <p:spPr>
+          <a:xfrm>
+            <a:off x="453553" y="1511808"/>
+            <a:ext cx="8705305" cy="487680"/>
+          </a:xfrm>
+          <a:prstGeom prst="rect">
+            <a:avLst/>
+          </a:prstGeom>
+          <a:noFill/>
+        </p:spPr>
+        <p:txBody>
+          <a:bodyPr wrap="square" anchor="t" lIns="0" rIns="0" tIns="0" bIns="0">
+            <a:spAutoFit/>
+          </a:bodyPr>
+          <a:lstStyle/>
+          <a:p>
+            <a:pPr algn="l">
+              <a:lnSpc>
+                <a:spcPct val="110000"/>
+              </a:lnSpc>
+              <a:spcAft>
+                <a:spcPts val="0"/>
+              </a:spcAft>
+            </a:pPr>
+            <a:r>
+              <a:rPr sz="1040" b="0" i="1">
+                <a:solidFill>
+                  <a:srgbClr val="556A83"/>
+                </a:solidFill>
+                <a:latin typeface="Arial"/>
+              </a:rPr>
+              <a:t>Volatility is not symmetric. PE’s true risk is levered downside; Athanase’s is mostly upside, so its real loss risk is a fraction of PE’s.</a:t>
+            </a:r>
+          </a:p>
+        </p:txBody>
+      </p:sp>
+      <p:pic>
+        <p:nvPicPr>
+          <p:cNvPr id="8" name="Picture 7" descr="pe_realrisk.png"/>
+          <p:cNvPicPr>
+            <a:picLocks noChangeAspect="1"/>
+          </p:cNvPicPr>
+          <p:nvPr/>
+        </p:nvPicPr>
+        <p:blipFill>
+          <a:blip r:embed="rId3"/>
+          <a:stretch>
+            <a:fillRect/>
+          </a:stretch>
+        </p:blipFill>
+        <p:spPr>
+          <a:xfrm>
+            <a:off x="402346" y="2223819"/>
+            <a:ext cx="4118476" cy="2889576"/>
+          </a:xfrm>
+          <a:prstGeom prst="rect">
+            <a:avLst/>
+          </a:prstGeom>
+        </p:spPr>
+      </p:pic>
+      <p:sp>
+        <p:nvSpPr>
+          <p:cNvPr id="9" name="Rectangle 8"/>
+          <p:cNvSpPr/>
+          <p:nvPr/>
+        </p:nvSpPr>
+        <p:spPr>
+          <a:xfrm>
+            <a:off x="5157345" y="2243328"/>
+            <a:ext cx="4169768" cy="1804416"/>
+          </a:xfrm>
+          <a:prstGeom prst="rect">
+            <a:avLst/>
+          </a:prstGeom>
+          <a:solidFill>
+            <a:srgbClr val="F6F7F9"/>
+          </a:solidFill>
+          <a:ln>
+            <a:noFill/>
+          </a:ln>
+          <a:effectLst/>
+        </p:spPr>
+        <p:style>
+          <a:lnRef idx="1">
+            <a:schemeClr val="accent1"/>
+          </a:lnRef>
+          <a:fillRef idx="3">
+            <a:schemeClr val="accent1"/>
+          </a:fillRef>
+          <a:effectRef idx="2">
+            <a:schemeClr val="accent1"/>
+          </a:effectRef>
+          <a:fontRef idx="minor">
+            <a:schemeClr val="lt1"/>
+          </a:fontRef>
+        </p:style>
+        <p:txBody>
+          <a:bodyPr rtlCol="0" anchor="ctr"/>
+          <a:lstStyle/>
+          <a:p>
+            <a:pPr algn="ctr"/>
+          </a:p>
+        </p:txBody>
+      </p:sp>
+      <p:sp>
+        <p:nvSpPr>
+          <p:cNvPr id="10" name="TextBox 9"/>
+          <p:cNvSpPr txBox="1"/>
+          <p:nvPr/>
+        </p:nvSpPr>
+        <p:spPr>
+          <a:xfrm>
+            <a:off x="5340229" y="2399385"/>
+            <a:ext cx="3803999" cy="292608"/>
+          </a:xfrm>
+          <a:prstGeom prst="rect">
+            <a:avLst/>
+          </a:prstGeom>
+          <a:noFill/>
+        </p:spPr>
+        <p:txBody>
+          <a:bodyPr wrap="square" anchor="t" lIns="0" rIns="0" tIns="0" bIns="0">
+            <a:spAutoFit/>
+          </a:bodyPr>
+          <a:lstStyle/>
+          <a:p>
+            <a:pPr algn="l">
+              <a:lnSpc>
+                <a:spcPct val="110000"/>
+              </a:lnSpc>
+              <a:spcAft>
+                <a:spcPts val="0"/>
+              </a:spcAft>
+            </a:pPr>
+            <a:r>
+              <a:rPr sz="880" b="1" i="0">
+                <a:solidFill>
+                  <a:srgbClr val="314359"/>
+                </a:solidFill>
+                <a:latin typeface="Arial"/>
+              </a:rPr>
+              <a:t>CHANCE OF A 30%+ LOSS OVER THREE YEARS</a:t>
+            </a:r>
+          </a:p>
+        </p:txBody>
+      </p:sp>
+      <p:sp>
+        <p:nvSpPr>
+          <p:cNvPr id="11" name="TextBox 10"/>
+          <p:cNvSpPr txBox="1"/>
+          <p:nvPr/>
+        </p:nvSpPr>
+        <p:spPr>
+          <a:xfrm>
+            <a:off x="5340229" y="2789529"/>
+            <a:ext cx="3803999" cy="1170432"/>
+          </a:xfrm>
+          <a:prstGeom prst="rect">
+            <a:avLst/>
+          </a:prstGeom>
+          <a:noFill/>
+        </p:spPr>
+        <p:txBody>
+          <a:bodyPr wrap="square" anchor="t" lIns="0" rIns="0" tIns="0" bIns="0">
+            <a:spAutoFit/>
+          </a:bodyPr>
+          <a:lstStyle/>
+          <a:p>
+            <a:pPr>
+              <a:spcAft>
+                <a:spcPts val="200"/>
+              </a:spcAft>
+            </a:pPr>
+            <a:r>
+              <a:rPr sz="2720" b="1">
+                <a:solidFill>
+                  <a:srgbClr val="556A83"/>
+                </a:solidFill>
+                <a:latin typeface="Times New Roman"/>
+              </a:rPr>
+              <a:t>~16%</a:t>
+            </a:r>
+            <a:r>
+              <a:rPr sz="1040">
+                <a:solidFill>
+                  <a:srgbClr val="556A83"/>
+                </a:solidFill>
+                <a:latin typeface="Arial"/>
+              </a:rPr>
+              <a:t>   private equity</a:t>
+            </a:r>
+          </a:p>
+          <a:p>
+            <a:r>
+              <a:rPr sz="2720" b="1">
+                <a:solidFill>
+                  <a:srgbClr val="152130"/>
+                </a:solidFill>
+                <a:latin typeface="Times New Roman"/>
+              </a:rPr>
+              <a:t>~2%</a:t>
+            </a:r>
+            <a:r>
+              <a:rPr sz="1040">
+                <a:solidFill>
+                  <a:srgbClr val="556A83"/>
+                </a:solidFill>
+                <a:latin typeface="Arial"/>
+              </a:rPr>
+              <a:t>   Athanase (actual 3-yr windows)</a:t>
+            </a:r>
+          </a:p>
+        </p:txBody>
+      </p:sp>
+      <p:sp>
+        <p:nvSpPr>
+          <p:cNvPr id="12" name="Rectangle 11"/>
+          <p:cNvSpPr/>
+          <p:nvPr/>
+        </p:nvSpPr>
+        <p:spPr>
+          <a:xfrm>
+            <a:off x="5157345" y="4291584"/>
+            <a:ext cx="4169768" cy="936345"/>
+          </a:xfrm>
+          <a:prstGeom prst="rect">
+            <a:avLst/>
+          </a:prstGeom>
+          <a:solidFill>
+            <a:srgbClr val="F6F7F9"/>
+          </a:solidFill>
+          <a:ln>
+            <a:noFill/>
+          </a:ln>
+          <a:effectLst/>
+        </p:spPr>
+        <p:style>
+          <a:lnRef idx="1">
+            <a:schemeClr val="accent1"/>
+          </a:lnRef>
+          <a:fillRef idx="3">
+            <a:schemeClr val="accent1"/>
+          </a:fillRef>
+          <a:effectRef idx="2">
+            <a:schemeClr val="accent1"/>
+          </a:effectRef>
+          <a:fontRef idx="minor">
+            <a:schemeClr val="lt1"/>
+          </a:fontRef>
+        </p:style>
+        <p:txBody>
+          <a:bodyPr rtlCol="0" anchor="ctr"/>
+          <a:lstStyle/>
+          <a:p>
+            <a:pPr algn="ctr"/>
+          </a:p>
+        </p:txBody>
+      </p:sp>
+      <p:sp>
+        <p:nvSpPr>
+          <p:cNvPr id="13" name="TextBox 12"/>
+          <p:cNvSpPr txBox="1"/>
+          <p:nvPr/>
+        </p:nvSpPr>
+        <p:spPr>
+          <a:xfrm>
+            <a:off x="5340229" y="4408627"/>
+            <a:ext cx="3803999" cy="243840"/>
+          </a:xfrm>
+          <a:prstGeom prst="rect">
+            <a:avLst/>
+          </a:prstGeom>
+          <a:noFill/>
+        </p:spPr>
+        <p:txBody>
+          <a:bodyPr wrap="square" anchor="t" lIns="0" rIns="0" tIns="0" bIns="0">
+            <a:spAutoFit/>
+          </a:bodyPr>
+          <a:lstStyle/>
+          <a:p>
+            <a:pPr algn="l">
+              <a:lnSpc>
+                <a:spcPct val="110000"/>
+              </a:lnSpc>
+              <a:spcAft>
+                <a:spcPts val="0"/>
+              </a:spcAft>
+            </a:pPr>
+            <a:r>
+              <a:rPr sz="840" b="1" i="0">
+                <a:solidFill>
+                  <a:srgbClr val="314359"/>
+                </a:solidFill>
+                <a:latin typeface="Arial"/>
+              </a:rPr>
+              <a:t>VOLATILITY ≠ RISK OF LOSS</a:t>
+            </a:r>
+          </a:p>
+        </p:txBody>
+      </p:sp>
+      <p:sp>
+        <p:nvSpPr>
+          <p:cNvPr id="14" name="TextBox 13"/>
+          <p:cNvSpPr txBox="1"/>
+          <p:nvPr/>
+        </p:nvSpPr>
+        <p:spPr>
+          <a:xfrm>
+            <a:off x="5340229" y="4662220"/>
+            <a:ext cx="3803999" cy="536448"/>
+          </a:xfrm>
+          <a:prstGeom prst="rect">
+            <a:avLst/>
+          </a:prstGeom>
+          <a:noFill/>
+        </p:spPr>
+        <p:txBody>
+          <a:bodyPr wrap="square" anchor="t" lIns="0" rIns="0" tIns="0" bIns="0">
+            <a:spAutoFit/>
+          </a:bodyPr>
+          <a:lstStyle/>
+          <a:p>
+            <a:pPr algn="l">
+              <a:lnSpc>
+                <a:spcPct val="112000"/>
+              </a:lnSpc>
+              <a:spcAft>
+                <a:spcPts val="0"/>
+              </a:spcAft>
+            </a:pPr>
+            <a:r>
+              <a:rPr sz="840" b="0" i="0">
+                <a:solidFill>
+                  <a:srgbClr val="0E1620"/>
+                </a:solidFill>
+                <a:latin typeface="Arial"/>
+              </a:rPr>
+              <a:t>PE’s ~28% true vol is dominated by downside (levered, left-skewed). Athanase’s 27% is mostly upside — downside deviation is only ~11%.</a:t>
+            </a:r>
+          </a:p>
+        </p:txBody>
+      </p:sp>
+      <p:sp>
+        <p:nvSpPr>
+          <p:cNvPr id="15" name="Rectangle 14"/>
+          <p:cNvSpPr/>
+          <p:nvPr/>
+        </p:nvSpPr>
+        <p:spPr>
+          <a:xfrm>
+            <a:off x="5157345" y="5344972"/>
+            <a:ext cx="4169768" cy="936345"/>
+          </a:xfrm>
+          <a:prstGeom prst="rect">
+            <a:avLst/>
+          </a:prstGeom>
+          <a:solidFill>
+            <a:srgbClr val="F6F7F9"/>
+          </a:solidFill>
+          <a:ln>
+            <a:noFill/>
+          </a:ln>
+          <a:effectLst/>
+        </p:spPr>
+        <p:style>
+          <a:lnRef idx="1">
+            <a:schemeClr val="accent1"/>
+          </a:lnRef>
+          <a:fillRef idx="3">
+            <a:schemeClr val="accent1"/>
+          </a:fillRef>
+          <a:effectRef idx="2">
+            <a:schemeClr val="accent1"/>
+          </a:effectRef>
+          <a:fontRef idx="minor">
+            <a:schemeClr val="lt1"/>
+          </a:fontRef>
+        </p:style>
+        <p:txBody>
+          <a:bodyPr rtlCol="0" anchor="ctr"/>
+          <a:lstStyle/>
+          <a:p>
+            <a:pPr algn="ctr"/>
+          </a:p>
+        </p:txBody>
+      </p:sp>
+      <p:sp>
+        <p:nvSpPr>
+          <p:cNvPr id="16" name="TextBox 15"/>
+          <p:cNvSpPr txBox="1"/>
+          <p:nvPr/>
+        </p:nvSpPr>
+        <p:spPr>
+          <a:xfrm>
+            <a:off x="5340229" y="5462016"/>
+            <a:ext cx="3803999" cy="243840"/>
+          </a:xfrm>
+          <a:prstGeom prst="rect">
+            <a:avLst/>
+          </a:prstGeom>
+          <a:noFill/>
+        </p:spPr>
+        <p:txBody>
+          <a:bodyPr wrap="square" anchor="t" lIns="0" rIns="0" tIns="0" bIns="0">
+            <a:spAutoFit/>
+          </a:bodyPr>
+          <a:lstStyle/>
+          <a:p>
+            <a:pPr algn="l">
+              <a:lnSpc>
+                <a:spcPct val="110000"/>
+              </a:lnSpc>
+              <a:spcAft>
+                <a:spcPts val="0"/>
+              </a:spcAft>
+            </a:pPr>
+            <a:r>
+              <a:rPr sz="840" b="1" i="0">
+                <a:solidFill>
+                  <a:srgbClr val="314359"/>
+                </a:solidFill>
+                <a:latin typeface="Arial"/>
+              </a:rPr>
+              <a:t>THE RISK THAT MATTERS</a:t>
+            </a:r>
+          </a:p>
+        </p:txBody>
+      </p:sp>
+      <p:sp>
+        <p:nvSpPr>
+          <p:cNvPr id="17" name="TextBox 16"/>
+          <p:cNvSpPr txBox="1"/>
+          <p:nvPr/>
+        </p:nvSpPr>
+        <p:spPr>
+          <a:xfrm>
+            <a:off x="5340229" y="5715609"/>
+            <a:ext cx="3803999" cy="536448"/>
+          </a:xfrm>
+          <a:prstGeom prst="rect">
+            <a:avLst/>
+          </a:prstGeom>
+          <a:noFill/>
+        </p:spPr>
+        <p:txBody>
+          <a:bodyPr wrap="square" anchor="t" lIns="0" rIns="0" tIns="0" bIns="0">
+            <a:spAutoFit/>
+          </a:bodyPr>
+          <a:lstStyle/>
+          <a:p>
+            <a:pPr algn="l">
+              <a:lnSpc>
+                <a:spcPct val="112000"/>
+              </a:lnSpc>
+              <a:spcAft>
+                <a:spcPts val="0"/>
+              </a:spcAft>
+            </a:pPr>
+            <a:r>
+              <a:rPr sz="840" b="0" i="0">
+                <a:solidFill>
+                  <a:srgbClr val="0E1620"/>
+                </a:solidFill>
+                <a:latin typeface="Arial"/>
+              </a:rPr>
+              <a:t>On the measure allocators actually care about — large permanent loss — Athanase’s real risk is roughly one-eighth of private equity’s.</a:t>
+            </a:r>
+          </a:p>
+        </p:txBody>
+      </p:sp>
+      <p:sp>
+        <p:nvSpPr>
+          <p:cNvPr id="18" name="Rectangle 17"/>
+          <p:cNvSpPr/>
+          <p:nvPr/>
+        </p:nvSpPr>
+        <p:spPr>
+          <a:xfrm>
+            <a:off x="438922" y="6456883"/>
+            <a:ext cx="8873559" cy="448665"/>
+          </a:xfrm>
+          <a:prstGeom prst="rect">
+            <a:avLst/>
+          </a:prstGeom>
+          <a:solidFill>
+            <a:srgbClr val="152130"/>
+          </a:solidFill>
+          <a:ln>
+            <a:noFill/>
+          </a:ln>
+          <a:effectLst/>
+        </p:spPr>
+        <p:style>
+          <a:lnRef idx="1">
+            <a:schemeClr val="accent1"/>
+          </a:lnRef>
+          <a:fillRef idx="3">
+            <a:schemeClr val="accent1"/>
+          </a:fillRef>
+          <a:effectRef idx="2">
+            <a:schemeClr val="accent1"/>
+          </a:effectRef>
+          <a:fontRef idx="minor">
+            <a:schemeClr val="lt1"/>
+          </a:fontRef>
+        </p:style>
+        <p:txBody>
+          <a:bodyPr rtlCol="0" anchor="ctr"/>
+          <a:lstStyle/>
+          <a:p>
+            <a:pPr algn="ctr"/>
+          </a:p>
+        </p:txBody>
+      </p:sp>
+      <p:sp>
+        <p:nvSpPr>
+          <p:cNvPr id="19" name="TextBox 18"/>
+          <p:cNvSpPr txBox="1"/>
+          <p:nvPr/>
+        </p:nvSpPr>
+        <p:spPr>
+          <a:xfrm>
+            <a:off x="570599" y="6456883"/>
+            <a:ext cx="8632151" cy="448665"/>
+          </a:xfrm>
+          <a:prstGeom prst="rect">
+            <a:avLst/>
+          </a:prstGeom>
+          <a:noFill/>
+        </p:spPr>
+        <p:txBody>
+          <a:bodyPr wrap="square" anchor="ctr" lIns="0" rIns="0" tIns="0" bIns="0">
+            <a:spAutoFit/>
+          </a:bodyPr>
+          <a:lstStyle/>
+          <a:p>
+            <a:pPr algn="l">
+              <a:lnSpc>
+                <a:spcPct val="110000"/>
+              </a:lnSpc>
+              <a:spcAft>
+                <a:spcPts val="0"/>
+              </a:spcAft>
+            </a:pPr>
+            <a:r>
+              <a:rPr sz="960" b="0" i="1">
+                <a:solidFill>
+                  <a:srgbClr val="FFFFFF"/>
+                </a:solidFill>
+                <a:latin typeface="Arial"/>
+              </a:rPr>
+              <a:t>Matched on true volatility, Athanase carries far less of the risk that actually hurts: its downside is a fraction of private equity’s.</a:t>
+            </a:r>
+          </a:p>
+        </p:txBody>
+      </p:sp>
+      <p:sp>
+        <p:nvSpPr>
+          <p:cNvPr id="20" name="TextBox 19"/>
+          <p:cNvSpPr txBox="1"/>
+          <p:nvPr/>
+        </p:nvSpPr>
+        <p:spPr>
+          <a:xfrm>
+            <a:off x="438922" y="6944563"/>
+            <a:ext cx="9217382" cy="487680"/>
+          </a:xfrm>
+          <a:prstGeom prst="rect">
+            <a:avLst/>
+          </a:prstGeom>
+          <a:noFill/>
+        </p:spPr>
+        <p:txBody>
+          <a:bodyPr wrap="square" anchor="t" lIns="0" rIns="0" tIns="0" bIns="0">
+            <a:spAutoFit/>
+          </a:bodyPr>
+          <a:lstStyle/>
+          <a:p>
+            <a:pPr algn="l">
+              <a:lnSpc>
+                <a:spcPct val="110000"/>
+              </a:lnSpc>
+              <a:spcAft>
+                <a:spcPts val="0"/>
+              </a:spcAft>
+            </a:pPr>
+            <a:r>
+              <a:rPr sz="600" b="0" i="0">
+                <a:solidFill>
+                  <a:srgbClr val="556A83"/>
+                </a:solidFill>
+                <a:latin typeface="Arial"/>
+              </a:rPr>
+              <a:t>Athanase downside vol 11% vs total 27% (real, 235 months); 30%+ loss in 2% of actual rolling 3-yr windows. PE de-smoothed total vol ~28%, ~15–16% chance of a 30% drawdown over 3 years (PIMCO, 2022). Illustrative; past performance ≠ future results.</a:t>
             </a:r>
           </a:p>
         </p:txBody>

</xml_diff>

<commit_message>
Add correlation slide: PE de-smoothed 0.89 (no real diversification) vs Athanase real 0.44; Two Sigma/Venn + crisis-correlation
</commit_message>
<xml_diff>
--- a/Athanase_vs_Private_Equity.pptx
+++ b/Athanase_vs_Private_Equity.pptx
@@ -9,6 +9,7 @@
     <p:sldId id="257" r:id="rId8"/>
     <p:sldId id="258" r:id="rId9"/>
     <p:sldId id="259" r:id="rId10"/>
+    <p:sldId id="260" r:id="rId11"/>
   </p:sldIdLst>
   <p:sldSz cx="9753600" cy="7315200" type="screen4x3"/>
   <p:notesSz cx="6858000" cy="9144000"/>
@@ -6891,6 +6892,796 @@
                 <a:latin typeface="Arial"/>
               </a:rPr>
               <a:t>Athanase downside vol 11% vs total 27% (real, 235 months); 30%+ loss in 2% of actual rolling 3-yr windows. PE de-smoothed total vol ~28%, ~15–16% chance of a 30% drawdown over 3 years (PIMCO, 2022). Illustrative; past performance ≠ future results.</a:t>
+            </a:r>
+          </a:p>
+        </p:txBody>
+      </p:sp>
+    </p:spTree>
+  </p:cSld>
+  <p:clrMapOvr>
+    <a:masterClrMapping/>
+  </p:clrMapOvr>
+</p:sld>
+</file>
+
+<file path=ppt/slides/slide5.xml><?xml version="1.0" encoding="utf-8"?>
+<p:sld xmlns:a="http://schemas.openxmlformats.org/drawingml/2006/main" xmlns:p="http://schemas.openxmlformats.org/presentationml/2006/main" xmlns:r="http://schemas.openxmlformats.org/officeDocument/2006/relationships">
+  <p:cSld>
+    <p:spTree>
+      <p:nvGrpSpPr>
+        <p:cNvPr id="1" name=""/>
+        <p:cNvGrpSpPr/>
+        <p:nvPr/>
+      </p:nvGrpSpPr>
+      <p:grpSpPr/>
+      <p:pic>
+        <p:nvPicPr>
+          <p:cNvPr id="2" name="Picture 1" descr="mark_dark.png"/>
+          <p:cNvPicPr>
+            <a:picLocks noChangeAspect="1"/>
+          </p:cNvPicPr>
+          <p:nvPr/>
+        </p:nvPicPr>
+        <p:blipFill>
+          <a:blip r:embed="rId2"/>
+          <a:stretch>
+            <a:fillRect/>
+          </a:stretch>
+        </p:blipFill>
+        <p:spPr>
+          <a:xfrm>
+            <a:off x="402346" y="234086"/>
+            <a:ext cx="224012" cy="190199"/>
+          </a:xfrm>
+          <a:prstGeom prst="rect">
+            <a:avLst/>
+          </a:prstGeom>
+        </p:spPr>
+      </p:pic>
+      <p:sp>
+        <p:nvSpPr>
+          <p:cNvPr id="3" name="TextBox 2"/>
+          <p:cNvSpPr txBox="1"/>
+          <p:nvPr/>
+        </p:nvSpPr>
+        <p:spPr>
+          <a:xfrm>
+            <a:off x="716907" y="263347"/>
+            <a:ext cx="5120768" cy="292608"/>
+          </a:xfrm>
+          <a:prstGeom prst="rect">
+            <a:avLst/>
+          </a:prstGeom>
+          <a:noFill/>
+        </p:spPr>
+        <p:txBody>
+          <a:bodyPr wrap="square" anchor="t" lIns="0" rIns="0" tIns="0" bIns="0">
+            <a:spAutoFit/>
+          </a:bodyPr>
+          <a:lstStyle/>
+          <a:p>
+            <a:pPr algn="l">
+              <a:lnSpc>
+                <a:spcPct val="110000"/>
+              </a:lnSpc>
+              <a:spcAft>
+                <a:spcPts val="0"/>
+              </a:spcAft>
+            </a:pPr>
+            <a:r>
+              <a:rPr sz="880" b="0" i="0">
+                <a:solidFill>
+                  <a:srgbClr val="556A83"/>
+                </a:solidFill>
+                <a:latin typeface="Arial"/>
+              </a:rPr>
+              <a:t>Risk-Adjusted Outcomes</a:t>
+            </a:r>
+          </a:p>
+        </p:txBody>
+      </p:sp>
+      <p:sp>
+        <p:nvSpPr>
+          <p:cNvPr id="4" name="TextBox 3"/>
+          <p:cNvSpPr txBox="1"/>
+          <p:nvPr/>
+        </p:nvSpPr>
+        <p:spPr>
+          <a:xfrm>
+            <a:off x="7242229" y="263347"/>
+            <a:ext cx="2084884" cy="292608"/>
+          </a:xfrm>
+          <a:prstGeom prst="rect">
+            <a:avLst/>
+          </a:prstGeom>
+          <a:noFill/>
+        </p:spPr>
+        <p:txBody>
+          <a:bodyPr wrap="square" anchor="t" lIns="0" rIns="0" tIns="0" bIns="0">
+            <a:spAutoFit/>
+          </a:bodyPr>
+          <a:lstStyle/>
+          <a:p>
+            <a:pPr algn="r">
+              <a:lnSpc>
+                <a:spcPct val="110000"/>
+              </a:lnSpc>
+              <a:spcAft>
+                <a:spcPts val="0"/>
+              </a:spcAft>
+            </a:pPr>
+            <a:r>
+              <a:rPr sz="880" b="1" i="0">
+                <a:solidFill>
+                  <a:srgbClr val="556A83"/>
+                </a:solidFill>
+                <a:latin typeface="Arial"/>
+              </a:rPr>
+              <a:t>Figure 5</a:t>
+            </a:r>
+          </a:p>
+        </p:txBody>
+      </p:sp>
+      <p:sp>
+        <p:nvSpPr>
+          <p:cNvPr id="5" name="Rectangle 4"/>
+          <p:cNvSpPr/>
+          <p:nvPr/>
+        </p:nvSpPr>
+        <p:spPr>
+          <a:xfrm>
+            <a:off x="0" y="604723"/>
+            <a:ext cx="9753600" cy="1414272"/>
+          </a:xfrm>
+          <a:prstGeom prst="rect">
+            <a:avLst/>
+          </a:prstGeom>
+          <a:solidFill>
+            <a:srgbClr val="F6F7F9"/>
+          </a:solidFill>
+          <a:ln>
+            <a:noFill/>
+          </a:ln>
+          <a:effectLst/>
+        </p:spPr>
+        <p:style>
+          <a:lnRef idx="1">
+            <a:schemeClr val="accent1"/>
+          </a:lnRef>
+          <a:fillRef idx="3">
+            <a:schemeClr val="accent1"/>
+          </a:fillRef>
+          <a:effectRef idx="2">
+            <a:schemeClr val="accent1"/>
+          </a:effectRef>
+          <a:fontRef idx="minor">
+            <a:schemeClr val="lt1"/>
+          </a:fontRef>
+        </p:style>
+        <p:txBody>
+          <a:bodyPr rtlCol="0" anchor="ctr"/>
+          <a:lstStyle/>
+          <a:p>
+            <a:pPr algn="ctr"/>
+          </a:p>
+        </p:txBody>
+      </p:sp>
+      <p:sp>
+        <p:nvSpPr>
+          <p:cNvPr id="6" name="TextBox 5"/>
+          <p:cNvSpPr txBox="1"/>
+          <p:nvPr/>
+        </p:nvSpPr>
+        <p:spPr>
+          <a:xfrm>
+            <a:off x="438922" y="721766"/>
+            <a:ext cx="8851613" cy="829056"/>
+          </a:xfrm>
+          <a:prstGeom prst="rect">
+            <a:avLst/>
+          </a:prstGeom>
+          <a:noFill/>
+        </p:spPr>
+        <p:txBody>
+          <a:bodyPr wrap="square" anchor="t" lIns="0" rIns="0" tIns="0" bIns="0">
+            <a:spAutoFit/>
+          </a:bodyPr>
+          <a:lstStyle/>
+          <a:p>
+            <a:pPr algn="l">
+              <a:lnSpc>
+                <a:spcPct val="110000"/>
+              </a:lnSpc>
+              <a:spcAft>
+                <a:spcPts val="200"/>
+              </a:spcAft>
+            </a:pPr>
+            <a:r>
+              <a:rPr sz="2400" b="0" i="0">
+                <a:solidFill>
+                  <a:srgbClr val="314359"/>
+                </a:solidFill>
+                <a:latin typeface="Times New Roman"/>
+              </a:rPr>
+              <a:t>PE’s “diversification” is an artefact — Athanase’s is real</a:t>
+            </a:r>
+          </a:p>
+        </p:txBody>
+      </p:sp>
+      <p:sp>
+        <p:nvSpPr>
+          <p:cNvPr id="7" name="TextBox 6"/>
+          <p:cNvSpPr txBox="1"/>
+          <p:nvPr/>
+        </p:nvSpPr>
+        <p:spPr>
+          <a:xfrm>
+            <a:off x="453553" y="1511808"/>
+            <a:ext cx="8705305" cy="487680"/>
+          </a:xfrm>
+          <a:prstGeom prst="rect">
+            <a:avLst/>
+          </a:prstGeom>
+          <a:noFill/>
+        </p:spPr>
+        <p:txBody>
+          <a:bodyPr wrap="square" anchor="t" lIns="0" rIns="0" tIns="0" bIns="0">
+            <a:spAutoFit/>
+          </a:bodyPr>
+          <a:lstStyle/>
+          <a:p>
+            <a:pPr algn="l">
+              <a:lnSpc>
+                <a:spcPct val="110000"/>
+              </a:lnSpc>
+              <a:spcAft>
+                <a:spcPts val="0"/>
+              </a:spcAft>
+            </a:pPr>
+            <a:r>
+              <a:rPr sz="1040" b="0" i="1">
+                <a:solidFill>
+                  <a:srgbClr val="556A83"/>
+                </a:solidFill>
+                <a:latin typeface="Arial"/>
+              </a:rPr>
+              <a:t>De-smoothed, PE is ~0.9 correlated to public equities: the same risk factors, just reported late. Athanase is genuinely uncorrelated.</a:t>
+            </a:r>
+          </a:p>
+        </p:txBody>
+      </p:sp>
+      <p:pic>
+        <p:nvPicPr>
+          <p:cNvPr id="8" name="Picture 7" descr="pe_corr.png"/>
+          <p:cNvPicPr>
+            <a:picLocks noChangeAspect="1"/>
+          </p:cNvPicPr>
+          <p:nvPr/>
+        </p:nvPicPr>
+        <p:blipFill>
+          <a:blip r:embed="rId3"/>
+          <a:stretch>
+            <a:fillRect/>
+          </a:stretch>
+        </p:blipFill>
+        <p:spPr>
+          <a:xfrm>
+            <a:off x="402346" y="2223819"/>
+            <a:ext cx="4268692" cy="2889576"/>
+          </a:xfrm>
+          <a:prstGeom prst="rect">
+            <a:avLst/>
+          </a:prstGeom>
+        </p:spPr>
+      </p:pic>
+      <p:sp>
+        <p:nvSpPr>
+          <p:cNvPr id="9" name="Rectangle 8"/>
+          <p:cNvSpPr/>
+          <p:nvPr/>
+        </p:nvSpPr>
+        <p:spPr>
+          <a:xfrm>
+            <a:off x="5267075" y="2243328"/>
+            <a:ext cx="4060037" cy="1150924"/>
+          </a:xfrm>
+          <a:prstGeom prst="rect">
+            <a:avLst/>
+          </a:prstGeom>
+          <a:solidFill>
+            <a:srgbClr val="F6F7F9"/>
+          </a:solidFill>
+          <a:ln>
+            <a:noFill/>
+          </a:ln>
+          <a:effectLst/>
+        </p:spPr>
+        <p:style>
+          <a:lnRef idx="1">
+            <a:schemeClr val="accent1"/>
+          </a:lnRef>
+          <a:fillRef idx="3">
+            <a:schemeClr val="accent1"/>
+          </a:fillRef>
+          <a:effectRef idx="2">
+            <a:schemeClr val="accent1"/>
+          </a:effectRef>
+          <a:fontRef idx="minor">
+            <a:schemeClr val="lt1"/>
+          </a:fontRef>
+        </p:style>
+        <p:txBody>
+          <a:bodyPr rtlCol="0" anchor="ctr"/>
+          <a:lstStyle/>
+          <a:p>
+            <a:pPr algn="ctr"/>
+          </a:p>
+        </p:txBody>
+      </p:sp>
+      <p:sp>
+        <p:nvSpPr>
+          <p:cNvPr id="10" name="TextBox 9"/>
+          <p:cNvSpPr txBox="1"/>
+          <p:nvPr/>
+        </p:nvSpPr>
+        <p:spPr>
+          <a:xfrm>
+            <a:off x="5428014" y="2360371"/>
+            <a:ext cx="3738160" cy="243840"/>
+          </a:xfrm>
+          <a:prstGeom prst="rect">
+            <a:avLst/>
+          </a:prstGeom>
+          <a:noFill/>
+        </p:spPr>
+        <p:txBody>
+          <a:bodyPr wrap="square" anchor="t" lIns="0" rIns="0" tIns="0" bIns="0">
+            <a:spAutoFit/>
+          </a:bodyPr>
+          <a:lstStyle/>
+          <a:p>
+            <a:pPr algn="l">
+              <a:lnSpc>
+                <a:spcPct val="110000"/>
+              </a:lnSpc>
+              <a:spcAft>
+                <a:spcPts val="0"/>
+              </a:spcAft>
+            </a:pPr>
+            <a:r>
+              <a:rPr sz="840" b="1" i="0">
+                <a:solidFill>
+                  <a:srgbClr val="314359"/>
+                </a:solidFill>
+                <a:latin typeface="Arial"/>
+              </a:rPr>
+              <a:t>THE SMOOTHING ILLUSION</a:t>
+            </a:r>
+          </a:p>
+        </p:txBody>
+      </p:sp>
+      <p:sp>
+        <p:nvSpPr>
+          <p:cNvPr id="11" name="TextBox 10"/>
+          <p:cNvSpPr txBox="1"/>
+          <p:nvPr/>
+        </p:nvSpPr>
+        <p:spPr>
+          <a:xfrm>
+            <a:off x="5428014" y="2613964"/>
+            <a:ext cx="3738160" cy="721766"/>
+          </a:xfrm>
+          <a:prstGeom prst="rect">
+            <a:avLst/>
+          </a:prstGeom>
+          <a:noFill/>
+        </p:spPr>
+        <p:txBody>
+          <a:bodyPr wrap="square" anchor="t" lIns="0" rIns="0" tIns="0" bIns="0">
+            <a:spAutoFit/>
+          </a:bodyPr>
+          <a:lstStyle/>
+          <a:p>
+            <a:pPr algn="l">
+              <a:lnSpc>
+                <a:spcPct val="112000"/>
+              </a:lnSpc>
+              <a:spcAft>
+                <a:spcPts val="0"/>
+              </a:spcAft>
+            </a:pPr>
+            <a:r>
+              <a:rPr sz="840" b="0" i="0">
+                <a:solidFill>
+                  <a:srgbClr val="0E1620"/>
+                </a:solidFill>
+                <a:latin typeface="Arial"/>
+              </a:rPr>
+              <a:t>Quarterly appraisals lag the market, so reported PE correlation looks low (0.75, beta 0.41). De-smoothed it is 0.89 / beta 0.87 (Two Sigma, 2024).</a:t>
+            </a:r>
+          </a:p>
+        </p:txBody>
+      </p:sp>
+      <p:sp>
+        <p:nvSpPr>
+          <p:cNvPr id="12" name="Rectangle 11"/>
+          <p:cNvSpPr/>
+          <p:nvPr/>
+        </p:nvSpPr>
+        <p:spPr>
+          <a:xfrm>
+            <a:off x="5267075" y="3530803"/>
+            <a:ext cx="4060037" cy="1150924"/>
+          </a:xfrm>
+          <a:prstGeom prst="rect">
+            <a:avLst/>
+          </a:prstGeom>
+          <a:solidFill>
+            <a:srgbClr val="F6F7F9"/>
+          </a:solidFill>
+          <a:ln>
+            <a:noFill/>
+          </a:ln>
+          <a:effectLst/>
+        </p:spPr>
+        <p:style>
+          <a:lnRef idx="1">
+            <a:schemeClr val="accent1"/>
+          </a:lnRef>
+          <a:fillRef idx="3">
+            <a:schemeClr val="accent1"/>
+          </a:fillRef>
+          <a:effectRef idx="2">
+            <a:schemeClr val="accent1"/>
+          </a:effectRef>
+          <a:fontRef idx="minor">
+            <a:schemeClr val="lt1"/>
+          </a:fontRef>
+        </p:style>
+        <p:txBody>
+          <a:bodyPr rtlCol="0" anchor="ctr"/>
+          <a:lstStyle/>
+          <a:p>
+            <a:pPr algn="ctr"/>
+          </a:p>
+        </p:txBody>
+      </p:sp>
+      <p:sp>
+        <p:nvSpPr>
+          <p:cNvPr id="13" name="TextBox 12"/>
+          <p:cNvSpPr txBox="1"/>
+          <p:nvPr/>
+        </p:nvSpPr>
+        <p:spPr>
+          <a:xfrm>
+            <a:off x="5428014" y="3647846"/>
+            <a:ext cx="3738160" cy="243840"/>
+          </a:xfrm>
+          <a:prstGeom prst="rect">
+            <a:avLst/>
+          </a:prstGeom>
+          <a:noFill/>
+        </p:spPr>
+        <p:txBody>
+          <a:bodyPr wrap="square" anchor="t" lIns="0" rIns="0" tIns="0" bIns="0">
+            <a:spAutoFit/>
+          </a:bodyPr>
+          <a:lstStyle/>
+          <a:p>
+            <a:pPr algn="l">
+              <a:lnSpc>
+                <a:spcPct val="110000"/>
+              </a:lnSpc>
+              <a:spcAft>
+                <a:spcPts val="0"/>
+              </a:spcAft>
+            </a:pPr>
+            <a:r>
+              <a:rPr sz="840" b="1" i="0">
+                <a:solidFill>
+                  <a:srgbClr val="314359"/>
+                </a:solidFill>
+                <a:latin typeface="Arial"/>
+              </a:rPr>
+              <a:t>SAME RISK FACTORS</a:t>
+            </a:r>
+          </a:p>
+        </p:txBody>
+      </p:sp>
+      <p:sp>
+        <p:nvSpPr>
+          <p:cNvPr id="14" name="TextBox 13"/>
+          <p:cNvSpPr txBox="1"/>
+          <p:nvPr/>
+        </p:nvSpPr>
+        <p:spPr>
+          <a:xfrm>
+            <a:off x="5428014" y="3901440"/>
+            <a:ext cx="3738160" cy="721766"/>
+          </a:xfrm>
+          <a:prstGeom prst="rect">
+            <a:avLst/>
+          </a:prstGeom>
+          <a:noFill/>
+        </p:spPr>
+        <p:txBody>
+          <a:bodyPr wrap="square" anchor="t" lIns="0" rIns="0" tIns="0" bIns="0">
+            <a:spAutoFit/>
+          </a:bodyPr>
+          <a:lstStyle/>
+          <a:p>
+            <a:pPr algn="l">
+              <a:lnSpc>
+                <a:spcPct val="112000"/>
+              </a:lnSpc>
+              <a:spcAft>
+                <a:spcPts val="0"/>
+              </a:spcAft>
+            </a:pPr>
+            <a:r>
+              <a:rPr sz="840" b="0" i="0">
+                <a:solidFill>
+                  <a:srgbClr val="0E1620"/>
+                </a:solidFill>
+                <a:latin typeface="Arial"/>
+              </a:rPr>
+              <a:t>PE is long-only levered equity driven by the same forces — GDP, rates, earnings. Over 10–20 yrs its correlation to small/mid-caps is ~0.89–0.92.</a:t>
+            </a:r>
+          </a:p>
+        </p:txBody>
+      </p:sp>
+      <p:sp>
+        <p:nvSpPr>
+          <p:cNvPr id="15" name="Rectangle 14"/>
+          <p:cNvSpPr/>
+          <p:nvPr/>
+        </p:nvSpPr>
+        <p:spPr>
+          <a:xfrm>
+            <a:off x="5267075" y="4818278"/>
+            <a:ext cx="4060037" cy="1150924"/>
+          </a:xfrm>
+          <a:prstGeom prst="rect">
+            <a:avLst/>
+          </a:prstGeom>
+          <a:solidFill>
+            <a:srgbClr val="F6F7F9"/>
+          </a:solidFill>
+          <a:ln>
+            <a:noFill/>
+          </a:ln>
+          <a:effectLst/>
+        </p:spPr>
+        <p:style>
+          <a:lnRef idx="1">
+            <a:schemeClr val="accent1"/>
+          </a:lnRef>
+          <a:fillRef idx="3">
+            <a:schemeClr val="accent1"/>
+          </a:fillRef>
+          <a:effectRef idx="2">
+            <a:schemeClr val="accent1"/>
+          </a:effectRef>
+          <a:fontRef idx="minor">
+            <a:schemeClr val="lt1"/>
+          </a:fontRef>
+        </p:style>
+        <p:txBody>
+          <a:bodyPr rtlCol="0" anchor="ctr"/>
+          <a:lstStyle/>
+          <a:p>
+            <a:pPr algn="ctr"/>
+          </a:p>
+        </p:txBody>
+      </p:sp>
+      <p:sp>
+        <p:nvSpPr>
+          <p:cNvPr id="16" name="TextBox 15"/>
+          <p:cNvSpPr txBox="1"/>
+          <p:nvPr/>
+        </p:nvSpPr>
+        <p:spPr>
+          <a:xfrm>
+            <a:off x="5428014" y="4935321"/>
+            <a:ext cx="3738160" cy="243840"/>
+          </a:xfrm>
+          <a:prstGeom prst="rect">
+            <a:avLst/>
+          </a:prstGeom>
+          <a:noFill/>
+        </p:spPr>
+        <p:txBody>
+          <a:bodyPr wrap="square" anchor="t" lIns="0" rIns="0" tIns="0" bIns="0">
+            <a:spAutoFit/>
+          </a:bodyPr>
+          <a:lstStyle/>
+          <a:p>
+            <a:pPr algn="l">
+              <a:lnSpc>
+                <a:spcPct val="110000"/>
+              </a:lnSpc>
+              <a:spcAft>
+                <a:spcPts val="0"/>
+              </a:spcAft>
+            </a:pPr>
+            <a:r>
+              <a:rPr sz="840" b="1" i="0">
+                <a:solidFill>
+                  <a:srgbClr val="314359"/>
+                </a:solidFill>
+                <a:latin typeface="Arial"/>
+              </a:rPr>
+              <a:t>THE CRISIS MIRAGE</a:t>
+            </a:r>
+          </a:p>
+        </p:txBody>
+      </p:sp>
+      <p:sp>
+        <p:nvSpPr>
+          <p:cNvPr id="17" name="TextBox 16"/>
+          <p:cNvSpPr txBox="1"/>
+          <p:nvPr/>
+        </p:nvSpPr>
+        <p:spPr>
+          <a:xfrm>
+            <a:off x="5428014" y="5188915"/>
+            <a:ext cx="3738160" cy="721766"/>
+          </a:xfrm>
+          <a:prstGeom prst="rect">
+            <a:avLst/>
+          </a:prstGeom>
+          <a:noFill/>
+        </p:spPr>
+        <p:txBody>
+          <a:bodyPr wrap="square" anchor="t" lIns="0" rIns="0" tIns="0" bIns="0">
+            <a:spAutoFit/>
+          </a:bodyPr>
+          <a:lstStyle/>
+          <a:p>
+            <a:pPr algn="l">
+              <a:lnSpc>
+                <a:spcPct val="112000"/>
+              </a:lnSpc>
+              <a:spcAft>
+                <a:spcPts val="0"/>
+              </a:spcAft>
+            </a:pPr>
+            <a:r>
+              <a:rPr sz="840" b="0" i="0">
+                <a:solidFill>
+                  <a:srgbClr val="0E1620"/>
+                </a:solidFill>
+                <a:latin typeface="Arial"/>
+              </a:rPr>
+              <a:t>In severe drawdowns true correlation converges toward 1.0 — PE takes the same hit, it just reports the markdown later. No help when it’s needed.</a:t>
+            </a:r>
+          </a:p>
+        </p:txBody>
+      </p:sp>
+      <p:sp>
+        <p:nvSpPr>
+          <p:cNvPr id="18" name="Rectangle 17"/>
+          <p:cNvSpPr/>
+          <p:nvPr/>
+        </p:nvSpPr>
+        <p:spPr>
+          <a:xfrm>
+            <a:off x="438922" y="6456883"/>
+            <a:ext cx="8873559" cy="448665"/>
+          </a:xfrm>
+          <a:prstGeom prst="rect">
+            <a:avLst/>
+          </a:prstGeom>
+          <a:solidFill>
+            <a:srgbClr val="152130"/>
+          </a:solidFill>
+          <a:ln>
+            <a:noFill/>
+          </a:ln>
+          <a:effectLst/>
+        </p:spPr>
+        <p:style>
+          <a:lnRef idx="1">
+            <a:schemeClr val="accent1"/>
+          </a:lnRef>
+          <a:fillRef idx="3">
+            <a:schemeClr val="accent1"/>
+          </a:fillRef>
+          <a:effectRef idx="2">
+            <a:schemeClr val="accent1"/>
+          </a:effectRef>
+          <a:fontRef idx="minor">
+            <a:schemeClr val="lt1"/>
+          </a:fontRef>
+        </p:style>
+        <p:txBody>
+          <a:bodyPr rtlCol="0" anchor="ctr"/>
+          <a:lstStyle/>
+          <a:p>
+            <a:pPr algn="ctr"/>
+          </a:p>
+        </p:txBody>
+      </p:sp>
+      <p:sp>
+        <p:nvSpPr>
+          <p:cNvPr id="19" name="TextBox 18"/>
+          <p:cNvSpPr txBox="1"/>
+          <p:nvPr/>
+        </p:nvSpPr>
+        <p:spPr>
+          <a:xfrm>
+            <a:off x="570599" y="6456883"/>
+            <a:ext cx="8632151" cy="448665"/>
+          </a:xfrm>
+          <a:prstGeom prst="rect">
+            <a:avLst/>
+          </a:prstGeom>
+          <a:noFill/>
+        </p:spPr>
+        <p:txBody>
+          <a:bodyPr wrap="square" anchor="ctr" lIns="0" rIns="0" tIns="0" bIns="0">
+            <a:spAutoFit/>
+          </a:bodyPr>
+          <a:lstStyle/>
+          <a:p>
+            <a:pPr algn="l">
+              <a:lnSpc>
+                <a:spcPct val="110000"/>
+              </a:lnSpc>
+              <a:spcAft>
+                <a:spcPts val="0"/>
+              </a:spcAft>
+            </a:pPr>
+            <a:r>
+              <a:rPr sz="960" b="0" i="1">
+                <a:solidFill>
+                  <a:srgbClr val="FFFFFF"/>
+                </a:solidFill>
+                <a:latin typeface="Arial"/>
+              </a:rPr>
+              <a:t>PE adds leveraged beta dressed as diversification. Athanase, at 0.44 correlation, is the genuine diversifier in a public-equity portfolio.</a:t>
+            </a:r>
+          </a:p>
+        </p:txBody>
+      </p:sp>
+      <p:sp>
+        <p:nvSpPr>
+          <p:cNvPr id="20" name="TextBox 19"/>
+          <p:cNvSpPr txBox="1"/>
+          <p:nvPr/>
+        </p:nvSpPr>
+        <p:spPr>
+          <a:xfrm>
+            <a:off x="438922" y="6944563"/>
+            <a:ext cx="9217382" cy="487680"/>
+          </a:xfrm>
+          <a:prstGeom prst="rect">
+            <a:avLst/>
+          </a:prstGeom>
+          <a:noFill/>
+        </p:spPr>
+        <p:txBody>
+          <a:bodyPr wrap="square" anchor="t" lIns="0" rIns="0" tIns="0" bIns="0">
+            <a:spAutoFit/>
+          </a:bodyPr>
+          <a:lstStyle/>
+          <a:p>
+            <a:pPr algn="l">
+              <a:lnSpc>
+                <a:spcPct val="110000"/>
+              </a:lnSpc>
+              <a:spcAft>
+                <a:spcPts val="0"/>
+              </a:spcAft>
+            </a:pPr>
+            <a:r>
+              <a:rPr sz="600" b="0" i="0">
+                <a:solidFill>
+                  <a:srgbClr val="556A83"/>
+                </a:solidFill>
+                <a:latin typeface="Arial"/>
+              </a:rPr>
+              <a:t>Athanase correlation 0.44 / beta 0.73 to MSCI World IMI (real, 235 months). PE reported 0.75 / beta 0.41 de-smoothed to 0.89 / beta 0.87 (Two Sigma / Venn, 2024, Preqin PE Index); long-horizon PE–small/mid cap correlation ~0.89–0.92. Illustrative; past performance ≠ future results.</a:t>
             </a:r>
           </a:p>
         </p:txBody>

</xml_diff>

<commit_message>
Add sources/references slide listing all academic and industry citations for verification
</commit_message>
<xml_diff>
--- a/Athanase_vs_Private_Equity.pptx
+++ b/Athanase_vs_Private_Equity.pptx
@@ -10,6 +10,7 @@
     <p:sldId id="258" r:id="rId9"/>
     <p:sldId id="259" r:id="rId10"/>
     <p:sldId id="260" r:id="rId11"/>
+    <p:sldId id="261" r:id="rId12"/>
   </p:sldIdLst>
   <p:sldSz cx="9753600" cy="7315200" type="screen4x3"/>
   <p:notesSz cx="6858000" cy="9144000"/>
@@ -7682,6 +7683,868 @@
                 <a:latin typeface="Arial"/>
               </a:rPr>
               <a:t>Athanase correlation 0.44 / beta 0.73 to MSCI World IMI (real, 235 months). PE reported 0.75 / beta 0.41 de-smoothed to 0.89 / beta 0.87 (Two Sigma / Venn, 2024, Preqin PE Index); long-horizon PE–small/mid cap correlation ~0.89–0.92. Illustrative; past performance ≠ future results.</a:t>
+            </a:r>
+          </a:p>
+        </p:txBody>
+      </p:sp>
+    </p:spTree>
+  </p:cSld>
+  <p:clrMapOvr>
+    <a:masterClrMapping/>
+  </p:clrMapOvr>
+</p:sld>
+</file>
+
+<file path=ppt/slides/slide6.xml><?xml version="1.0" encoding="utf-8"?>
+<p:sld xmlns:a="http://schemas.openxmlformats.org/drawingml/2006/main" xmlns:p="http://schemas.openxmlformats.org/presentationml/2006/main" xmlns:r="http://schemas.openxmlformats.org/officeDocument/2006/relationships">
+  <p:cSld>
+    <p:spTree>
+      <p:nvGrpSpPr>
+        <p:cNvPr id="1" name=""/>
+        <p:cNvGrpSpPr/>
+        <p:nvPr/>
+      </p:nvGrpSpPr>
+      <p:grpSpPr/>
+      <p:pic>
+        <p:nvPicPr>
+          <p:cNvPr id="2" name="Picture 1" descr="mark_dark.png"/>
+          <p:cNvPicPr>
+            <a:picLocks noChangeAspect="1"/>
+          </p:cNvPicPr>
+          <p:nvPr/>
+        </p:nvPicPr>
+        <p:blipFill>
+          <a:blip r:embed="rId2"/>
+          <a:stretch>
+            <a:fillRect/>
+          </a:stretch>
+        </p:blipFill>
+        <p:spPr>
+          <a:xfrm>
+            <a:off x="402346" y="234086"/>
+            <a:ext cx="224012" cy="190199"/>
+          </a:xfrm>
+          <a:prstGeom prst="rect">
+            <a:avLst/>
+          </a:prstGeom>
+        </p:spPr>
+      </p:pic>
+      <p:sp>
+        <p:nvSpPr>
+          <p:cNvPr id="3" name="TextBox 2"/>
+          <p:cNvSpPr txBox="1"/>
+          <p:nvPr/>
+        </p:nvSpPr>
+        <p:spPr>
+          <a:xfrm>
+            <a:off x="716907" y="263347"/>
+            <a:ext cx="5120768" cy="292608"/>
+          </a:xfrm>
+          <a:prstGeom prst="rect">
+            <a:avLst/>
+          </a:prstGeom>
+          <a:noFill/>
+        </p:spPr>
+        <p:txBody>
+          <a:bodyPr wrap="square" anchor="t" lIns="0" rIns="0" tIns="0" bIns="0">
+            <a:spAutoFit/>
+          </a:bodyPr>
+          <a:lstStyle/>
+          <a:p>
+            <a:pPr algn="l">
+              <a:lnSpc>
+                <a:spcPct val="110000"/>
+              </a:lnSpc>
+              <a:spcAft>
+                <a:spcPts val="0"/>
+              </a:spcAft>
+            </a:pPr>
+            <a:r>
+              <a:rPr sz="880" b="0" i="0">
+                <a:solidFill>
+                  <a:srgbClr val="556A83"/>
+                </a:solidFill>
+                <a:latin typeface="Arial"/>
+              </a:rPr>
+              <a:t>Risk-Adjusted Outcomes</a:t>
+            </a:r>
+          </a:p>
+        </p:txBody>
+      </p:sp>
+      <p:sp>
+        <p:nvSpPr>
+          <p:cNvPr id="4" name="TextBox 3"/>
+          <p:cNvSpPr txBox="1"/>
+          <p:nvPr/>
+        </p:nvSpPr>
+        <p:spPr>
+          <a:xfrm>
+            <a:off x="7242229" y="263347"/>
+            <a:ext cx="2084884" cy="292608"/>
+          </a:xfrm>
+          <a:prstGeom prst="rect">
+            <a:avLst/>
+          </a:prstGeom>
+          <a:noFill/>
+        </p:spPr>
+        <p:txBody>
+          <a:bodyPr wrap="square" anchor="t" lIns="0" rIns="0" tIns="0" bIns="0">
+            <a:spAutoFit/>
+          </a:bodyPr>
+          <a:lstStyle/>
+          <a:p>
+            <a:pPr algn="r">
+              <a:lnSpc>
+                <a:spcPct val="110000"/>
+              </a:lnSpc>
+              <a:spcAft>
+                <a:spcPts val="0"/>
+              </a:spcAft>
+            </a:pPr>
+            <a:r>
+              <a:rPr sz="880" b="1" i="0">
+                <a:solidFill>
+                  <a:srgbClr val="556A83"/>
+                </a:solidFill>
+                <a:latin typeface="Arial"/>
+              </a:rPr>
+              <a:t>References</a:t>
+            </a:r>
+          </a:p>
+        </p:txBody>
+      </p:sp>
+      <p:sp>
+        <p:nvSpPr>
+          <p:cNvPr id="5" name="Rectangle 4"/>
+          <p:cNvSpPr/>
+          <p:nvPr/>
+        </p:nvSpPr>
+        <p:spPr>
+          <a:xfrm>
+            <a:off x="0" y="604723"/>
+            <a:ext cx="9753600" cy="1414272"/>
+          </a:xfrm>
+          <a:prstGeom prst="rect">
+            <a:avLst/>
+          </a:prstGeom>
+          <a:solidFill>
+            <a:srgbClr val="F6F7F9"/>
+          </a:solidFill>
+          <a:ln>
+            <a:noFill/>
+          </a:ln>
+          <a:effectLst/>
+        </p:spPr>
+        <p:style>
+          <a:lnRef idx="1">
+            <a:schemeClr val="accent1"/>
+          </a:lnRef>
+          <a:fillRef idx="3">
+            <a:schemeClr val="accent1"/>
+          </a:fillRef>
+          <a:effectRef idx="2">
+            <a:schemeClr val="accent1"/>
+          </a:effectRef>
+          <a:fontRef idx="minor">
+            <a:schemeClr val="lt1"/>
+          </a:fontRef>
+        </p:style>
+        <p:txBody>
+          <a:bodyPr rtlCol="0" anchor="ctr"/>
+          <a:lstStyle/>
+          <a:p>
+            <a:pPr algn="ctr"/>
+          </a:p>
+        </p:txBody>
+      </p:sp>
+      <p:sp>
+        <p:nvSpPr>
+          <p:cNvPr id="6" name="TextBox 5"/>
+          <p:cNvSpPr txBox="1"/>
+          <p:nvPr/>
+        </p:nvSpPr>
+        <p:spPr>
+          <a:xfrm>
+            <a:off x="438922" y="721766"/>
+            <a:ext cx="8851613" cy="829056"/>
+          </a:xfrm>
+          <a:prstGeom prst="rect">
+            <a:avLst/>
+          </a:prstGeom>
+          <a:noFill/>
+        </p:spPr>
+        <p:txBody>
+          <a:bodyPr wrap="square" anchor="t" lIns="0" rIns="0" tIns="0" bIns="0">
+            <a:spAutoFit/>
+          </a:bodyPr>
+          <a:lstStyle/>
+          <a:p>
+            <a:pPr algn="l">
+              <a:lnSpc>
+                <a:spcPct val="110000"/>
+              </a:lnSpc>
+              <a:spcAft>
+                <a:spcPts val="200"/>
+              </a:spcAft>
+            </a:pPr>
+            <a:r>
+              <a:rPr sz="2400" b="0" i="0">
+                <a:solidFill>
+                  <a:srgbClr val="314359"/>
+                </a:solidFill>
+                <a:latin typeface="Times New Roman"/>
+              </a:rPr>
+              <a:t>Sources</a:t>
+            </a:r>
+          </a:p>
+        </p:txBody>
+      </p:sp>
+      <p:sp>
+        <p:nvSpPr>
+          <p:cNvPr id="7" name="TextBox 6"/>
+          <p:cNvSpPr txBox="1"/>
+          <p:nvPr/>
+        </p:nvSpPr>
+        <p:spPr>
+          <a:xfrm>
+            <a:off x="453553" y="1511808"/>
+            <a:ext cx="8705305" cy="487680"/>
+          </a:xfrm>
+          <a:prstGeom prst="rect">
+            <a:avLst/>
+          </a:prstGeom>
+          <a:noFill/>
+        </p:spPr>
+        <p:txBody>
+          <a:bodyPr wrap="square" anchor="t" lIns="0" rIns="0" tIns="0" bIns="0">
+            <a:spAutoFit/>
+          </a:bodyPr>
+          <a:lstStyle/>
+          <a:p>
+            <a:pPr algn="l">
+              <a:lnSpc>
+                <a:spcPct val="110000"/>
+              </a:lnSpc>
+              <a:spcAft>
+                <a:spcPts val="0"/>
+              </a:spcAft>
+            </a:pPr>
+            <a:r>
+              <a:rPr sz="1040" b="0" i="1">
+                <a:solidFill>
+                  <a:srgbClr val="556A83"/>
+                </a:solidFill>
+                <a:latin typeface="Arial"/>
+              </a:rPr>
+              <a:t>Every private-equity figure traces to published research; every Athanase figure is computed from audited net monthly returns, 2006–2025.</a:t>
+            </a:r>
+          </a:p>
+        </p:txBody>
+      </p:sp>
+      <p:sp>
+        <p:nvSpPr>
+          <p:cNvPr id="8" name="TextBox 7"/>
+          <p:cNvSpPr txBox="1"/>
+          <p:nvPr/>
+        </p:nvSpPr>
+        <p:spPr>
+          <a:xfrm>
+            <a:off x="438922" y="2292096"/>
+            <a:ext cx="4389229" cy="292608"/>
+          </a:xfrm>
+          <a:prstGeom prst="rect">
+            <a:avLst/>
+          </a:prstGeom>
+          <a:noFill/>
+        </p:spPr>
+        <p:txBody>
+          <a:bodyPr wrap="square" anchor="t" lIns="0" rIns="0" tIns="0" bIns="0">
+            <a:spAutoFit/>
+          </a:bodyPr>
+          <a:lstStyle/>
+          <a:p>
+            <a:pPr algn="l">
+              <a:lnSpc>
+                <a:spcPct val="110000"/>
+              </a:lnSpc>
+              <a:spcAft>
+                <a:spcPts val="0"/>
+              </a:spcAft>
+            </a:pPr>
+            <a:r>
+              <a:rPr sz="919" b="1" i="0">
+                <a:solidFill>
+                  <a:srgbClr val="314359"/>
+                </a:solidFill>
+                <a:latin typeface="Arial"/>
+              </a:rPr>
+              <a:t>ACADEMIC &amp; EMPIRICAL RESEARCH</a:t>
+            </a:r>
+          </a:p>
+        </p:txBody>
+      </p:sp>
+      <p:sp>
+        <p:nvSpPr>
+          <p:cNvPr id="9" name="TextBox 8"/>
+          <p:cNvSpPr txBox="1"/>
+          <p:nvPr/>
+        </p:nvSpPr>
+        <p:spPr>
+          <a:xfrm>
+            <a:off x="438922" y="2682240"/>
+            <a:ext cx="4389229" cy="4486656"/>
+          </a:xfrm>
+          <a:prstGeom prst="rect">
+            <a:avLst/>
+          </a:prstGeom>
+          <a:noFill/>
+        </p:spPr>
+        <p:txBody>
+          <a:bodyPr wrap="square" anchor="t" lIns="0" rIns="0" tIns="0" bIns="0">
+            <a:spAutoFit/>
+          </a:bodyPr>
+          <a:lstStyle/>
+          <a:p>
+            <a:pPr>
+              <a:lnSpc>
+                <a:spcPct val="106000"/>
+              </a:lnSpc>
+              <a:spcAft>
+                <a:spcPts val="700"/>
+              </a:spcAft>
+            </a:pPr>
+            <a:r>
+              <a:rPr sz="760" b="1">
+                <a:solidFill>
+                  <a:srgbClr val="314359"/>
+                </a:solidFill>
+                <a:latin typeface="Arial"/>
+              </a:rPr>
+              <a:t>Ang, Chen, Goetzmann &amp; Phalippou (2018), J. Finance 73(4), 1751–1783.</a:t>
+            </a:r>
+            <a:r>
+              <a:rPr sz="760">
+                <a:solidFill>
+                  <a:srgbClr val="0E1620"/>
+                </a:solidFill>
+                <a:latin typeface="Arial"/>
+              </a:rPr>
+              <a:t>  — PE cash-flow returns; buyout vol ~25% vs 11% index, beta &gt; 1.</a:t>
+            </a:r>
+          </a:p>
+          <a:p>
+            <a:pPr>
+              <a:lnSpc>
+                <a:spcPct val="106000"/>
+              </a:lnSpc>
+              <a:spcAft>
+                <a:spcPts val="700"/>
+              </a:spcAft>
+            </a:pPr>
+            <a:r>
+              <a:rPr sz="760" b="1">
+                <a:solidFill>
+                  <a:srgbClr val="314359"/>
+                </a:solidFill>
+                <a:latin typeface="Arial"/>
+              </a:rPr>
+              <a:t>Boyer, Nadauld, Vorkink &amp; Weisbach (2018), SSRN 3272357.</a:t>
+            </a:r>
+            <a:r>
+              <a:rPr sz="760">
+                <a:solidFill>
+                  <a:srgbClr val="0E1620"/>
+                </a:solidFill>
+                <a:latin typeface="Arial"/>
+              </a:rPr>
+              <a:t>  — Secondary-market PE index; traded beta &gt; 2.0 vs &lt; 0.5 on NAV.</a:t>
+            </a:r>
+          </a:p>
+          <a:p>
+            <a:pPr>
+              <a:lnSpc>
+                <a:spcPct val="106000"/>
+              </a:lnSpc>
+              <a:spcAft>
+                <a:spcPts val="700"/>
+              </a:spcAft>
+            </a:pPr>
+            <a:r>
+              <a:rPr sz="760" b="1">
+                <a:solidFill>
+                  <a:srgbClr val="314359"/>
+                </a:solidFill>
+                <a:latin typeface="Arial"/>
+              </a:rPr>
+              <a:t>Getmansky, Lo &amp; Makarov (2004), J. Financial Economics 74(3).</a:t>
+            </a:r>
+            <a:r>
+              <a:rPr sz="760">
+                <a:solidFill>
+                  <a:srgbClr val="0E1620"/>
+                </a:solidFill>
+                <a:latin typeface="Arial"/>
+              </a:rPr>
+              <a:t>  — Illiquidity creates serial correlation that suppresses reported vol.</a:t>
+            </a:r>
+          </a:p>
+          <a:p>
+            <a:pPr>
+              <a:lnSpc>
+                <a:spcPct val="106000"/>
+              </a:lnSpc>
+              <a:spcAft>
+                <a:spcPts val="700"/>
+              </a:spcAft>
+            </a:pPr>
+            <a:r>
+              <a:rPr sz="760" b="1">
+                <a:solidFill>
+                  <a:srgbClr val="314359"/>
+                </a:solidFill>
+                <a:latin typeface="Arial"/>
+              </a:rPr>
+              <a:t>Couts, Gonçalves &amp; Rossi (2020), SSRN 3544854.</a:t>
+            </a:r>
+            <a:r>
+              <a:rPr sz="760">
+                <a:solidFill>
+                  <a:srgbClr val="0E1620"/>
+                </a:solidFill>
+                <a:latin typeface="Arial"/>
+              </a:rPr>
+              <a:t>  — 3-step unsmoothing; true vol and market co-movement rise.</a:t>
+            </a:r>
+          </a:p>
+          <a:p>
+            <a:pPr>
+              <a:lnSpc>
+                <a:spcPct val="106000"/>
+              </a:lnSpc>
+              <a:spcAft>
+                <a:spcPts val="700"/>
+              </a:spcAft>
+            </a:pPr>
+            <a:r>
+              <a:rPr sz="760" b="1">
+                <a:solidFill>
+                  <a:srgbClr val="314359"/>
+                </a:solidFill>
+                <a:latin typeface="Arial"/>
+              </a:rPr>
+              <a:t>Jackson, Ling &amp; Naranjo (2022), SSRN 4244467.</a:t>
+            </a:r>
+            <a:r>
+              <a:rPr sz="760">
+                <a:solidFill>
+                  <a:srgbClr val="0E1620"/>
+                </a:solidFill>
+                <a:latin typeface="Arial"/>
+              </a:rPr>
+              <a:t>  — Catering / return manipulation — “volatility laundering”.</a:t>
+            </a:r>
+          </a:p>
+          <a:p>
+            <a:pPr>
+              <a:lnSpc>
+                <a:spcPct val="106000"/>
+              </a:lnSpc>
+              <a:spcAft>
+                <a:spcPts val="700"/>
+              </a:spcAft>
+            </a:pPr>
+            <a:r>
+              <a:rPr sz="760" b="1">
+                <a:solidFill>
+                  <a:srgbClr val="314359"/>
+                </a:solidFill>
+                <a:latin typeface="Arial"/>
+              </a:rPr>
+              <a:t>Phalippou (2020), “An Inconvenient Fact.”</a:t>
+            </a:r>
+            <a:r>
+              <a:rPr sz="760">
+                <a:solidFill>
+                  <a:srgbClr val="0E1620"/>
+                </a:solidFill>
+                <a:latin typeface="Arial"/>
+              </a:rPr>
+              <a:t>  — PE 2006–18 ≈ S&amp;P 500 on a public-market-equivalent basis.</a:t>
+            </a:r>
+          </a:p>
+          <a:p>
+            <a:pPr>
+              <a:lnSpc>
+                <a:spcPct val="106000"/>
+              </a:lnSpc>
+              <a:spcAft>
+                <a:spcPts val="700"/>
+              </a:spcAft>
+            </a:pPr>
+            <a:r>
+              <a:rPr sz="760" b="1">
+                <a:solidFill>
+                  <a:srgbClr val="314359"/>
+                </a:solidFill>
+                <a:latin typeface="Arial"/>
+              </a:rPr>
+              <a:t>Meyer (2020), J. Alternative Investments 23; Hayley &amp; Sefiloglu (2022); Buchner, Kaserer &amp; Wagner (2010).</a:t>
+            </a:r>
+            <a:r>
+              <a:rPr sz="760">
+                <a:solidFill>
+                  <a:srgbClr val="0E1620"/>
+                </a:solidFill>
+                <a:latin typeface="Arial"/>
+              </a:rPr>
+              <a:t>  — Committed-capital / undrawn-commitment drag on realised returns.</a:t>
+            </a:r>
+          </a:p>
+        </p:txBody>
+      </p:sp>
+      <p:sp>
+        <p:nvSpPr>
+          <p:cNvPr id="10" name="TextBox 9"/>
+          <p:cNvSpPr txBox="1"/>
+          <p:nvPr/>
+        </p:nvSpPr>
+        <p:spPr>
+          <a:xfrm>
+            <a:off x="5084191" y="2292096"/>
+            <a:ext cx="4279499" cy="292608"/>
+          </a:xfrm>
+          <a:prstGeom prst="rect">
+            <a:avLst/>
+          </a:prstGeom>
+          <a:noFill/>
+        </p:spPr>
+        <p:txBody>
+          <a:bodyPr wrap="square" anchor="t" lIns="0" rIns="0" tIns="0" bIns="0">
+            <a:spAutoFit/>
+          </a:bodyPr>
+          <a:lstStyle/>
+          <a:p>
+            <a:pPr algn="l">
+              <a:lnSpc>
+                <a:spcPct val="110000"/>
+              </a:lnSpc>
+              <a:spcAft>
+                <a:spcPts val="0"/>
+              </a:spcAft>
+            </a:pPr>
+            <a:r>
+              <a:rPr sz="919" b="1" i="0">
+                <a:solidFill>
+                  <a:srgbClr val="314359"/>
+                </a:solidFill>
+                <a:latin typeface="Arial"/>
+              </a:rPr>
+              <a:t>INDUSTRY DATASETS &amp; PRACTITIONER RESEARCH</a:t>
+            </a:r>
+          </a:p>
+        </p:txBody>
+      </p:sp>
+      <p:sp>
+        <p:nvSpPr>
+          <p:cNvPr id="11" name="TextBox 10"/>
+          <p:cNvSpPr txBox="1"/>
+          <p:nvPr/>
+        </p:nvSpPr>
+        <p:spPr>
+          <a:xfrm>
+            <a:off x="5084191" y="2682240"/>
+            <a:ext cx="4279499" cy="4486656"/>
+          </a:xfrm>
+          <a:prstGeom prst="rect">
+            <a:avLst/>
+          </a:prstGeom>
+          <a:noFill/>
+        </p:spPr>
+        <p:txBody>
+          <a:bodyPr wrap="square" anchor="t" lIns="0" rIns="0" tIns="0" bIns="0">
+            <a:spAutoFit/>
+          </a:bodyPr>
+          <a:lstStyle/>
+          <a:p>
+            <a:pPr>
+              <a:lnSpc>
+                <a:spcPct val="106000"/>
+              </a:lnSpc>
+              <a:spcAft>
+                <a:spcPts val="700"/>
+              </a:spcAft>
+            </a:pPr>
+            <a:r>
+              <a:rPr sz="760" b="1">
+                <a:solidFill>
+                  <a:srgbClr val="314359"/>
+                </a:solidFill>
+                <a:latin typeface="Arial"/>
+              </a:rPr>
+              <a:t>Cliffwater (2023), State of US State Pension PE.</a:t>
+            </a:r>
+            <a:r>
+              <a:rPr sz="760">
+                <a:solidFill>
+                  <a:srgbClr val="0E1620"/>
+                </a:solidFill>
+                <a:latin typeface="Arial"/>
+              </a:rPr>
+              <a:t>  — Realised PE 11.4% vs PME 5.8%, 2000–2022.</a:t>
+            </a:r>
+          </a:p>
+          <a:p>
+            <a:pPr>
+              <a:lnSpc>
+                <a:spcPct val="106000"/>
+              </a:lnSpc>
+              <a:spcAft>
+                <a:spcPts val="700"/>
+              </a:spcAft>
+            </a:pPr>
+            <a:r>
+              <a:rPr sz="760" b="1">
+                <a:solidFill>
+                  <a:srgbClr val="314359"/>
+                </a:solidFill>
+                <a:latin typeface="Arial"/>
+              </a:rPr>
+              <a:t>BVCA / Capital Dynamics (2024), PME+ analysis.</a:t>
+            </a:r>
+            <a:r>
+              <a:rPr sz="760">
+                <a:solidFill>
+                  <a:srgbClr val="0E1620"/>
+                </a:solidFill>
+                <a:latin typeface="Arial"/>
+              </a:rPr>
+              <a:t>  — UK &amp; Europe PE 14.1% vs PME 7.7%, 2001–2023.</a:t>
+            </a:r>
+          </a:p>
+          <a:p>
+            <a:pPr>
+              <a:lnSpc>
+                <a:spcPct val="106000"/>
+              </a:lnSpc>
+              <a:spcAft>
+                <a:spcPts val="700"/>
+              </a:spcAft>
+            </a:pPr>
+            <a:r>
+              <a:rPr sz="760" b="1">
+                <a:solidFill>
+                  <a:srgbClr val="314359"/>
+                </a:solidFill>
+                <a:latin typeface="Arial"/>
+              </a:rPr>
+              <a:t>Cambridge Associates (2024), US PE Benchmark.</a:t>
+            </a:r>
+            <a:r>
+              <a:rPr sz="760">
+                <a:solidFill>
+                  <a:srgbClr val="0E1620"/>
+                </a:solidFill>
+                <a:latin typeface="Arial"/>
+              </a:rPr>
+              <a:t>  — Top-quartile headline IRR ~18–22%; mPME ~1.15–1.25×.</a:t>
+            </a:r>
+          </a:p>
+          <a:p>
+            <a:pPr>
+              <a:lnSpc>
+                <a:spcPct val="106000"/>
+              </a:lnSpc>
+              <a:spcAft>
+                <a:spcPts val="700"/>
+              </a:spcAft>
+            </a:pPr>
+            <a:r>
+              <a:rPr sz="760" b="1">
+                <a:solidFill>
+                  <a:srgbClr val="314359"/>
+                </a:solidFill>
+                <a:latin typeface="Arial"/>
+              </a:rPr>
+              <a:t>Kaplan, Harris &amp; Jenkinson (Burgiss data).</a:t>
+            </a:r>
+            <a:r>
+              <a:rPr sz="760">
+                <a:solidFill>
+                  <a:srgbClr val="0E1620"/>
+                </a:solidFill>
+                <a:latin typeface="Arial"/>
+              </a:rPr>
+              <a:t>  — KS-PME ~1.20–1.27×; ≈ +3 pts/yr net over public markets.</a:t>
+            </a:r>
+          </a:p>
+          <a:p>
+            <a:pPr>
+              <a:lnSpc>
+                <a:spcPct val="106000"/>
+              </a:lnSpc>
+              <a:spcAft>
+                <a:spcPts val="700"/>
+              </a:spcAft>
+            </a:pPr>
+            <a:r>
+              <a:rPr sz="760" b="1">
+                <a:solidFill>
+                  <a:srgbClr val="314359"/>
+                </a:solidFill>
+                <a:latin typeface="Arial"/>
+              </a:rPr>
+              <a:t>PIMCO (2022), “The Discreet Charm of Private Assets.”</a:t>
+            </a:r>
+            <a:r>
+              <a:rPr sz="760">
+                <a:solidFill>
+                  <a:srgbClr val="0E1620"/>
+                </a:solidFill>
+                <a:latin typeface="Arial"/>
+              </a:rPr>
+              <a:t>  — De-smoothed PE vol ~30%; ~15–16% chance of a 30% 3-yr drawdown.</a:t>
+            </a:r>
+          </a:p>
+          <a:p>
+            <a:pPr>
+              <a:lnSpc>
+                <a:spcPct val="106000"/>
+              </a:lnSpc>
+              <a:spcAft>
+                <a:spcPts val="700"/>
+              </a:spcAft>
+            </a:pPr>
+            <a:r>
+              <a:rPr sz="760" b="1">
+                <a:solidFill>
+                  <a:srgbClr val="314359"/>
+                </a:solidFill>
+                <a:latin typeface="Arial"/>
+              </a:rPr>
+              <a:t>AQR / Asness (2019–2023), “Volatility Laundering.”</a:t>
+            </a:r>
+            <a:r>
+              <a:rPr sz="760">
+                <a:solidFill>
+                  <a:srgbClr val="0E1620"/>
+                </a:solidFill>
+                <a:latin typeface="Arial"/>
+              </a:rPr>
+              <a:t>  — PE equity beta ~1.5–1.6 from leverage; smoothing critique.</a:t>
+            </a:r>
+          </a:p>
+          <a:p>
+            <a:pPr>
+              <a:lnSpc>
+                <a:spcPct val="106000"/>
+              </a:lnSpc>
+              <a:spcAft>
+                <a:spcPts val="700"/>
+              </a:spcAft>
+            </a:pPr>
+            <a:r>
+              <a:rPr sz="760" b="1">
+                <a:solidFill>
+                  <a:srgbClr val="314359"/>
+                </a:solidFill>
+                <a:latin typeface="Arial"/>
+              </a:rPr>
+              <a:t>Two Sigma / Venn (2024), Preqin PE Index analysis.</a:t>
+            </a:r>
+            <a:r>
+              <a:rPr sz="760">
+                <a:solidFill>
+                  <a:srgbClr val="0E1620"/>
+                </a:solidFill>
+                <a:latin typeface="Arial"/>
+              </a:rPr>
+              <a:t>  — Correlation 0.75→0.89, beta 0.41→0.87 once de-smoothed.</a:t>
+            </a:r>
+          </a:p>
+        </p:txBody>
+      </p:sp>
+      <p:sp>
+        <p:nvSpPr>
+          <p:cNvPr id="12" name="Rectangle 11"/>
+          <p:cNvSpPr/>
+          <p:nvPr/>
+        </p:nvSpPr>
+        <p:spPr>
+          <a:xfrm>
+            <a:off x="438922" y="6778752"/>
+            <a:ext cx="8873559" cy="409651"/>
+          </a:xfrm>
+          <a:prstGeom prst="rect">
+            <a:avLst/>
+          </a:prstGeom>
+          <a:solidFill>
+            <a:srgbClr val="F6F7F9"/>
+          </a:solidFill>
+          <a:ln>
+            <a:noFill/>
+          </a:ln>
+          <a:effectLst/>
+        </p:spPr>
+        <p:style>
+          <a:lnRef idx="1">
+            <a:schemeClr val="accent1"/>
+          </a:lnRef>
+          <a:fillRef idx="3">
+            <a:schemeClr val="accent1"/>
+          </a:fillRef>
+          <a:effectRef idx="2">
+            <a:schemeClr val="accent1"/>
+          </a:effectRef>
+          <a:fontRef idx="minor">
+            <a:schemeClr val="lt1"/>
+          </a:fontRef>
+        </p:style>
+        <p:txBody>
+          <a:bodyPr rtlCol="0" anchor="ctr"/>
+          <a:lstStyle/>
+          <a:p>
+            <a:pPr algn="ctr"/>
+          </a:p>
+        </p:txBody>
+      </p:sp>
+      <p:sp>
+        <p:nvSpPr>
+          <p:cNvPr id="13" name="TextBox 12"/>
+          <p:cNvSpPr txBox="1"/>
+          <p:nvPr/>
+        </p:nvSpPr>
+        <p:spPr>
+          <a:xfrm>
+            <a:off x="570599" y="6778752"/>
+            <a:ext cx="8632151" cy="409651"/>
+          </a:xfrm>
+          <a:prstGeom prst="rect">
+            <a:avLst/>
+          </a:prstGeom>
+          <a:noFill/>
+        </p:spPr>
+        <p:txBody>
+          <a:bodyPr wrap="square" anchor="ctr" lIns="0" rIns="0" tIns="0" bIns="0">
+            <a:spAutoFit/>
+          </a:bodyPr>
+          <a:lstStyle/>
+          <a:p>
+            <a:pPr algn="l">
+              <a:lnSpc>
+                <a:spcPct val="110000"/>
+              </a:lnSpc>
+              <a:spcAft>
+                <a:spcPts val="0"/>
+              </a:spcAft>
+            </a:pPr>
+            <a:r>
+              <a:rPr sz="760" b="0" i="1">
+                <a:solidFill>
+                  <a:srgbClr val="556A83"/>
+                </a:solidFill>
+                <a:latin typeface="Arial"/>
+              </a:rPr>
+              <a:t>Athanase returns, volatility, downside deviation, correlation and rolling loss frequencies are computed directly from the fund’s net monthly return series (2006–2025).</a:t>
             </a:r>
           </a:p>
         </p:txBody>

</xml_diff>